<commit_message>
Results presentation: add calendar-month threshold-window results (both defs)
Both definitions were already computed on BOTH windows (centered 15-day + calendar
month); this surfaces the month-window numbers that were only in the CSVs before.
- RESULTS_PRESENTATION.md: new "Threshold-window robustness" section (15-day vs
  month per definition; agree <1%, r~=0.99).
- Results deck: added a threshold-window robustness slide.

Co-Authored-By: Claude Opus 4.8 <noreply@anthropic.com>
</commit_message>
<xml_diff>
--- a/reference/Heatwave_Results_Deck.pptx
+++ b/reference/Heatwave_Results_Deck.pptx
@@ -25,6 +25,7 @@
     <p:sldId id="273" r:id="rId24"/>
     <p:sldId id="274" r:id="rId25"/>
     <p:sldId id="275" r:id="rId26"/>
+    <p:sldId id="276" r:id="rId27"/>
   </p:sldIdLst>
   <p:sldSz cx="12191695" cy="6858000" type="screen4x3"/>
   <p:notesSz cx="6858000" cy="9144000"/>
@@ -3565,6 +3566,434 @@
       <p:grpSpPr/>
       <p:sp>
         <p:nvSpPr>
+          <p:cNvPr id="2" name="TextBox 1"/>
+          <p:cNvSpPr txBox="1"/>
+          <p:nvPr/>
+        </p:nvSpPr>
+        <p:spPr>
+          <a:xfrm>
+            <a:off x="457200" y="228600"/>
+            <a:ext cx="11247120" cy="914400"/>
+          </a:xfrm>
+          <a:prstGeom prst="rect">
+            <a:avLst/>
+          </a:prstGeom>
+          <a:noFill/>
+        </p:spPr>
+        <p:txBody>
+          <a:bodyPr wrap="square">
+            <a:spAutoFit/>
+          </a:bodyPr>
+          <a:lstStyle/>
+          <a:p>
+            <a:r>
+              <a:rPr sz="2400" b="1">
+                <a:solidFill>
+                  <a:srgbClr val="1F3A5F"/>
+                </a:solidFill>
+              </a:rPr>
+              <a:t>Both definitions were run on BOTH threshold windows</a:t>
+            </a:r>
+          </a:p>
+          <a:p>
+            <a:r>
+              <a:rPr sz="1200">
+                <a:solidFill>
+                  <a:srgbClr val="555555"/>
+                </a:solidFill>
+              </a:rPr>
+              <a:t>Centered 15-day (primary, shown) vs calendar-month bucket — both computed for each definition</a:t>
+            </a:r>
+          </a:p>
+        </p:txBody>
+      </p:sp>
+      <p:graphicFrame>
+        <p:nvGraphicFramePr>
+          <p:cNvPr id="3" name="Table 2"/>
+          <p:cNvGraphicFramePr>
+            <a:graphicFrameLocks noGrp="1"/>
+          </p:cNvGraphicFramePr>
+          <p:nvPr/>
+        </p:nvGraphicFramePr>
+        <p:xfrm>
+          <a:off x="548640" y="1371600"/>
+          <a:ext cx="11064240" cy="2816352"/>
+        </p:xfrm>
+        <a:graphic>
+          <a:graphicData uri="http://schemas.openxmlformats.org/drawingml/2006/table">
+            <a:tbl>
+              <a:tblPr firstRow="1" bandRow="1">
+                <a:tableStyleId>{5C22544A-7EE6-4342-B048-85BDC9FD1C3A}</a:tableStyleId>
+              </a:tblPr>
+              <a:tblGrid>
+                <a:gridCol w="6583680"/>
+                <a:gridCol w="4480560"/>
+              </a:tblGrid>
+              <a:tr h="402336">
+                <a:tc>
+                  <a:txBody>
+                    <a:bodyPr/>
+                    <a:lstStyle/>
+                    <a:p>
+                      <a:r>
+                        <a:rPr b="1" sz="1300">
+                          <a:solidFill>
+                            <a:srgbClr val="FFFFFF"/>
+                          </a:solidFill>
+                        </a:rPr>
+                        <a:t>Statistic</a:t>
+                      </a:r>
+                    </a:p>
+                  </a:txBody>
+                  <a:tcPr anchor="ctr">
+                    <a:solidFill>
+                      <a:srgbClr val="1F3A5F"/>
+                    </a:solidFill>
+                  </a:tcPr>
+                </a:tc>
+                <a:tc>
+                  <a:txBody>
+                    <a:bodyPr/>
+                    <a:lstStyle/>
+                    <a:p>
+                      <a:r>
+                        <a:rPr b="1" sz="1300">
+                          <a:solidFill>
+                            <a:srgbClr val="FFFFFF"/>
+                          </a:solidFill>
+                        </a:rPr>
+                        <a:t>Value</a:t>
+                      </a:r>
+                    </a:p>
+                  </a:txBody>
+                  <a:tcPr anchor="ctr">
+                    <a:solidFill>
+                      <a:srgbClr val="1F3A5F"/>
+                    </a:solidFill>
+                  </a:tcPr>
+                </a:tc>
+              </a:tr>
+              <a:tr h="402336">
+                <a:tc>
+                  <a:txBody>
+                    <a:bodyPr/>
+                    <a:lstStyle/>
+                    <a:p>
+                      <a:r>
+                        <a:rPr sz="1200" b="0">
+                          <a:solidFill>
+                            <a:srgbClr val="1F3A5F"/>
+                          </a:solidFill>
+                        </a:rPr>
+                        <a:t>Def 01 pooled days — 15-day / month</a:t>
+                      </a:r>
+                    </a:p>
+                  </a:txBody>
+                  <a:tcPr anchor="ctr">
+                    <a:solidFill>
+                      <a:srgbClr val="FFFFFF"/>
+                    </a:solidFill>
+                  </a:tcPr>
+                </a:tc>
+                <a:tc>
+                  <a:txBody>
+                    <a:bodyPr/>
+                    <a:lstStyle/>
+                    <a:p>
+                      <a:r>
+                        <a:rPr sz="1200" b="1">
+                          <a:solidFill>
+                            <a:srgbClr val="222222"/>
+                          </a:solidFill>
+                        </a:rPr>
+                        <a:t>170,894 / 171,115</a:t>
+                      </a:r>
+                    </a:p>
+                  </a:txBody>
+                  <a:tcPr anchor="ctr">
+                    <a:solidFill>
+                      <a:srgbClr val="FFFFFF"/>
+                    </a:solidFill>
+                  </a:tcPr>
+                </a:tc>
+              </a:tr>
+              <a:tr h="402336">
+                <a:tc>
+                  <a:txBody>
+                    <a:bodyPr/>
+                    <a:lstStyle/>
+                    <a:p>
+                      <a:r>
+                        <a:rPr sz="1200" b="0">
+                          <a:solidFill>
+                            <a:srgbClr val="1F3A5F"/>
+                          </a:solidFill>
+                        </a:rPr>
+                        <a:t>Def 01 pooled events — 15-day / month</a:t>
+                      </a:r>
+                    </a:p>
+                  </a:txBody>
+                  <a:tcPr anchor="ctr">
+                    <a:solidFill>
+                      <a:srgbClr val="EFF1F5"/>
+                    </a:solidFill>
+                  </a:tcPr>
+                </a:tc>
+                <a:tc>
+                  <a:txBody>
+                    <a:bodyPr/>
+                    <a:lstStyle/>
+                    <a:p>
+                      <a:r>
+                        <a:rPr sz="1200" b="1">
+                          <a:solidFill>
+                            <a:srgbClr val="222222"/>
+                          </a:solidFill>
+                        </a:rPr>
+                        <a:t>48,323 / 47,470</a:t>
+                      </a:r>
+                    </a:p>
+                  </a:txBody>
+                  <a:tcPr anchor="ctr">
+                    <a:solidFill>
+                      <a:srgbClr val="EFF1F5"/>
+                    </a:solidFill>
+                  </a:tcPr>
+                </a:tc>
+              </a:tr>
+              <a:tr h="402336">
+                <a:tc>
+                  <a:txBody>
+                    <a:bodyPr/>
+                    <a:lstStyle/>
+                    <a:p>
+                      <a:r>
+                        <a:rPr sz="1200" b="0">
+                          <a:solidFill>
+                            <a:srgbClr val="1F3A5F"/>
+                          </a:solidFill>
+                        </a:rPr>
+                        <a:t>Def 01 per-county median days — 15-day / month</a:t>
+                      </a:r>
+                    </a:p>
+                  </a:txBody>
+                  <a:tcPr anchor="ctr">
+                    <a:solidFill>
+                      <a:srgbClr val="FFFFFF"/>
+                    </a:solidFill>
+                  </a:tcPr>
+                </a:tc>
+                <a:tc>
+                  <a:txBody>
+                    <a:bodyPr/>
+                    <a:lstStyle/>
+                    <a:p>
+                      <a:r>
+                        <a:rPr sz="1200" b="1">
+                          <a:solidFill>
+                            <a:srgbClr val="222222"/>
+                          </a:solidFill>
+                        </a:rPr>
+                        <a:t>677 / 678   (r = 0.994)</a:t>
+                      </a:r>
+                    </a:p>
+                  </a:txBody>
+                  <a:tcPr anchor="ctr">
+                    <a:solidFill>
+                      <a:srgbClr val="FFFFFF"/>
+                    </a:solidFill>
+                  </a:tcPr>
+                </a:tc>
+              </a:tr>
+              <a:tr h="402336">
+                <a:tc>
+                  <a:txBody>
+                    <a:bodyPr/>
+                    <a:lstStyle/>
+                    <a:p>
+                      <a:r>
+                        <a:rPr sz="1200" b="0">
+                          <a:solidFill>
+                            <a:srgbClr val="1F3A5F"/>
+                          </a:solidFill>
+                        </a:rPr>
+                        <a:t>Def 02 pooled days — 15-day / month</a:t>
+                      </a:r>
+                    </a:p>
+                  </a:txBody>
+                  <a:tcPr anchor="ctr">
+                    <a:solidFill>
+                      <a:srgbClr val="EFF1F5"/>
+                    </a:solidFill>
+                  </a:tcPr>
+                </a:tc>
+                <a:tc>
+                  <a:txBody>
+                    <a:bodyPr/>
+                    <a:lstStyle/>
+                    <a:p>
+                      <a:r>
+                        <a:rPr sz="1200" b="1">
+                          <a:solidFill>
+                            <a:srgbClr val="222222"/>
+                          </a:solidFill>
+                        </a:rPr>
+                        <a:t>52,786 / 53,273</a:t>
+                      </a:r>
+                    </a:p>
+                  </a:txBody>
+                  <a:tcPr anchor="ctr">
+                    <a:solidFill>
+                      <a:srgbClr val="EFF1F5"/>
+                    </a:solidFill>
+                  </a:tcPr>
+                </a:tc>
+              </a:tr>
+              <a:tr h="402336">
+                <a:tc>
+                  <a:txBody>
+                    <a:bodyPr/>
+                    <a:lstStyle/>
+                    <a:p>
+                      <a:r>
+                        <a:rPr sz="1200" b="0">
+                          <a:solidFill>
+                            <a:srgbClr val="1F3A5F"/>
+                          </a:solidFill>
+                        </a:rPr>
+                        <a:t>Def 02 pooled events — 15-day / month</a:t>
+                      </a:r>
+                    </a:p>
+                  </a:txBody>
+                  <a:tcPr anchor="ctr">
+                    <a:solidFill>
+                      <a:srgbClr val="FFFFFF"/>
+                    </a:solidFill>
+                  </a:tcPr>
+                </a:tc>
+                <a:tc>
+                  <a:txBody>
+                    <a:bodyPr/>
+                    <a:lstStyle/>
+                    <a:p>
+                      <a:r>
+                        <a:rPr sz="1200" b="1">
+                          <a:solidFill>
+                            <a:srgbClr val="222222"/>
+                          </a:solidFill>
+                        </a:rPr>
+                        <a:t>17,428 / 17,517</a:t>
+                      </a:r>
+                    </a:p>
+                  </a:txBody>
+                  <a:tcPr anchor="ctr">
+                    <a:solidFill>
+                      <a:srgbClr val="FFFFFF"/>
+                    </a:solidFill>
+                  </a:tcPr>
+                </a:tc>
+              </a:tr>
+              <a:tr h="402336">
+                <a:tc>
+                  <a:txBody>
+                    <a:bodyPr/>
+                    <a:lstStyle/>
+                    <a:p>
+                      <a:r>
+                        <a:rPr sz="1200" b="0">
+                          <a:solidFill>
+                            <a:srgbClr val="1F3A5F"/>
+                          </a:solidFill>
+                        </a:rPr>
+                        <a:t>Def 02 per-county median days — 15-day / month</a:t>
+                      </a:r>
+                    </a:p>
+                  </a:txBody>
+                  <a:tcPr anchor="ctr">
+                    <a:solidFill>
+                      <a:srgbClr val="EFF1F5"/>
+                    </a:solidFill>
+                  </a:tcPr>
+                </a:tc>
+                <a:tc>
+                  <a:txBody>
+                    <a:bodyPr/>
+                    <a:lstStyle/>
+                    <a:p>
+                      <a:r>
+                        <a:rPr sz="1200" b="1">
+                          <a:solidFill>
+                            <a:srgbClr val="222222"/>
+                          </a:solidFill>
+                        </a:rPr>
+                        <a:t>196 / 194   (r = 0.987)</a:t>
+                      </a:r>
+                    </a:p>
+                  </a:txBody>
+                  <a:tcPr anchor="ctr">
+                    <a:solidFill>
+                      <a:srgbClr val="EFF1F5"/>
+                    </a:solidFill>
+                  </a:tcPr>
+                </a:tc>
+              </a:tr>
+            </a:tbl>
+          </a:graphicData>
+        </a:graphic>
+      </p:graphicFrame>
+      <p:sp>
+        <p:nvSpPr>
+          <p:cNvPr id="4" name="TextBox 3"/>
+          <p:cNvSpPr txBox="1"/>
+          <p:nvPr/>
+        </p:nvSpPr>
+        <p:spPr>
+          <a:xfrm>
+            <a:off x="457200" y="6437376"/>
+            <a:ext cx="11247120" cy="365760"/>
+          </a:xfrm>
+          <a:prstGeom prst="rect">
+            <a:avLst/>
+          </a:prstGeom>
+          <a:noFill/>
+        </p:spPr>
+        <p:txBody>
+          <a:bodyPr wrap="square">
+            <a:spAutoFit/>
+          </a:bodyPr>
+          <a:lstStyle/>
+          <a:p>
+            <a:r>
+              <a:rPr sz="800" i="1">
+                <a:solidFill>
+                  <a:srgbClr val="555555"/>
+                </a:solidFill>
+              </a:rPr>
+              <a:t>The two windows agree to &lt;1% and r~=0.99 per county -&gt; the window choice is a robustness check, not a driver. Month-window CSVs: *_month.csv in each def's tables/ folder.</a:t>
+            </a:r>
+          </a:p>
+        </p:txBody>
+      </p:sp>
+    </p:spTree>
+  </p:cSld>
+  <p:clrMapOvr>
+    <a:masterClrMapping/>
+  </p:clrMapOvr>
+</p:sld>
+</file>
+
+<file path=ppt/slides/slide14.xml><?xml version="1.0" encoding="utf-8"?>
+<p:sld xmlns:a="http://schemas.openxmlformats.org/drawingml/2006/main" xmlns:p="http://schemas.openxmlformats.org/presentationml/2006/main" xmlns:r="http://schemas.openxmlformats.org/officeDocument/2006/relationships">
+  <p:cSld>
+    <p:spTree>
+      <p:nvGrpSpPr>
+        <p:cNvPr id="1" name=""/>
+        <p:cNvGrpSpPr/>
+        <p:nvPr/>
+      </p:nvGrpSpPr>
+      <p:grpSpPr/>
+      <p:sp>
+        <p:nvSpPr>
           <p:cNvPr id="2" name="Rectangle 1"/>
           <p:cNvSpPr/>
           <p:nvPr/>
@@ -3622,7 +4051,7 @@
 </p:sld>
 </file>
 
-<file path=ppt/slides/slide14.xml><?xml version="1.0" encoding="utf-8"?>
+<file path=ppt/slides/slide15.xml><?xml version="1.0" encoding="utf-8"?>
 <p:sld xmlns:a="http://schemas.openxmlformats.org/drawingml/2006/main" xmlns:p="http://schemas.openxmlformats.org/presentationml/2006/main" xmlns:r="http://schemas.openxmlformats.org/officeDocument/2006/relationships">
   <p:cSld>
     <p:spTree>
@@ -3801,7 +4230,7 @@
 </p:sld>
 </file>
 
-<file path=ppt/slides/slide15.xml><?xml version="1.0" encoding="utf-8"?>
+<file path=ppt/slides/slide16.xml><?xml version="1.0" encoding="utf-8"?>
 <p:sld xmlns:a="http://schemas.openxmlformats.org/drawingml/2006/main" xmlns:p="http://schemas.openxmlformats.org/presentationml/2006/main" xmlns:r="http://schemas.openxmlformats.org/officeDocument/2006/relationships">
   <p:cSld>
     <p:spTree>
@@ -3870,7 +4299,7 @@
 </p:sld>
 </file>
 
-<file path=ppt/slides/slide16.xml><?xml version="1.0" encoding="utf-8"?>
+<file path=ppt/slides/slide17.xml><?xml version="1.0" encoding="utf-8"?>
 <p:sld xmlns:a="http://schemas.openxmlformats.org/drawingml/2006/main" xmlns:p="http://schemas.openxmlformats.org/presentationml/2006/main" xmlns:r="http://schemas.openxmlformats.org/officeDocument/2006/relationships">
   <p:cSld>
     <p:spTree>
@@ -4007,155 +4436,6 @@
                 </a:solidFill>
               </a:rPr>
               <a:t>A: It's an approximate NWS proxy from GHCN-Daily temp + gridMET humidity. Regional gradient robust; single-county values &amp; trend slopes are descriptive only.</a:t>
-            </a:r>
-          </a:p>
-        </p:txBody>
-      </p:sp>
-    </p:spTree>
-  </p:cSld>
-  <p:clrMapOvr>
-    <a:masterClrMapping/>
-  </p:clrMapOvr>
-</p:sld>
-</file>
-
-<file path=ppt/slides/slide17.xml><?xml version="1.0" encoding="utf-8"?>
-<p:sld xmlns:a="http://schemas.openxmlformats.org/drawingml/2006/main" xmlns:p="http://schemas.openxmlformats.org/presentationml/2006/main" xmlns:r="http://schemas.openxmlformats.org/officeDocument/2006/relationships">
-  <p:cSld>
-    <p:spTree>
-      <p:nvGrpSpPr>
-        <p:cNvPr id="1" name=""/>
-        <p:cNvGrpSpPr/>
-        <p:nvPr/>
-      </p:nvGrpSpPr>
-      <p:grpSpPr/>
-      <p:sp>
-        <p:nvSpPr>
-          <p:cNvPr id="2" name="TextBox 1"/>
-          <p:cNvSpPr txBox="1"/>
-          <p:nvPr/>
-        </p:nvSpPr>
-        <p:spPr>
-          <a:xfrm>
-            <a:off x="457200" y="228600"/>
-            <a:ext cx="11247120" cy="914400"/>
-          </a:xfrm>
-          <a:prstGeom prst="rect">
-            <a:avLst/>
-          </a:prstGeom>
-          <a:noFill/>
-        </p:spPr>
-        <p:txBody>
-          <a:bodyPr wrap="square">
-            <a:spAutoFit/>
-          </a:bodyPr>
-          <a:lstStyle/>
-          <a:p>
-            <a:r>
-              <a:rPr sz="2400" b="1">
-                <a:solidFill>
-                  <a:srgbClr val="1F3A5F"/>
-                </a:solidFill>
-              </a:rPr>
-              <a:t>Likely questions — data quality &amp; persistence</a:t>
-            </a:r>
-          </a:p>
-        </p:txBody>
-      </p:sp>
-      <p:sp>
-        <p:nvSpPr>
-          <p:cNvPr id="3" name="TextBox 2"/>
-          <p:cNvSpPr txBox="1"/>
-          <p:nvPr/>
-        </p:nvSpPr>
-        <p:spPr>
-          <a:xfrm>
-            <a:off x="548640" y="1325880"/>
-            <a:ext cx="11064240" cy="5029200"/>
-          </a:xfrm>
-          <a:prstGeom prst="rect">
-            <a:avLst/>
-          </a:prstGeom>
-          <a:noFill/>
-        </p:spPr>
-        <p:txBody>
-          <a:bodyPr wrap="square">
-            <a:spAutoFit/>
-          </a:bodyPr>
-          <a:lstStyle/>
-          <a:p>
-            <a:pPr>
-              <a:spcBef>
-                <a:spcPts val="600"/>
-              </a:spcBef>
-            </a:pPr>
-            <a:r>
-              <a:rPr sz="1300" b="1">
-                <a:solidFill>
-                  <a:srgbClr val="1F3A5F"/>
-                </a:solidFill>
-              </a:rPr>
-              <a:t>Q: With ~13% of county-days imputed and 22 counties fully imputed, can I trust the maps?</a:t>
-            </a:r>
-          </a:p>
-          <a:p>
-            <a:r>
-              <a:rPr sz="1100">
-                <a:solidFill>
-                  <a:srgbClr val="555555"/>
-                </a:solidFill>
-              </a:rPr>
-              <a:t>A: Regionally yes, pixel-by-pixel no. Fully-imputed counties are interpolated, not observed — flag/exclude them for single-county claims. Statewide totals don't hinge on any one county.</a:t>
-            </a:r>
-          </a:p>
-          <a:p>
-            <a:pPr>
-              <a:spcBef>
-                <a:spcPts val="600"/>
-              </a:spcBef>
-            </a:pPr>
-            <a:r>
-              <a:rPr sz="1300" b="1">
-                <a:solidFill>
-                  <a:srgbClr val="1F3A5F"/>
-                </a:solidFill>
-              </a:rPr>
-              <a:t>Q: Is a 2-day exceedance really a 'wave', and is a 48-day event credible?</a:t>
-            </a:r>
-          </a:p>
-          <a:p>
-            <a:r>
-              <a:rPr sz="1100">
-                <a:solidFill>
-                  <a:srgbClr val="555555"/>
-                </a:solidFill>
-              </a:rPr>
-              <a:t>A: The &gt;=2-day rule is a minimum-persistence filter; 44–53% of events are exactly 2 days, so 'elevated exposure' is fairer than 'wave' for much of it. Long tails are genuine persistent anomalies — lead with the median, not the max.</a:t>
-            </a:r>
-          </a:p>
-          <a:p>
-            <a:pPr>
-              <a:spcBef>
-                <a:spcPts val="600"/>
-              </a:spcBef>
-            </a:pPr>
-            <a:r>
-              <a:rPr sz="1300" b="1">
-                <a:solidFill>
-                  <a:srgbClr val="1F3A5F"/>
-                </a:solidFill>
-              </a:rPr>
-              <a:t>Q: Some adjacent counties differ sharply — is that real climate?</a:t>
-            </a:r>
-          </a:p>
-          <a:p>
-            <a:r>
-              <a:rPr sz="1100">
-                <a:solidFill>
-                  <a:srgbClr val="555555"/>
-                </a:solidFill>
-              </a:rPr>
-              <a:t>A: Largely no — it reflects the changing multi-station composite + IDW imputation, not micro-climate. That's why single-county rankings are presented cautiously.</a:t>
             </a:r>
           </a:p>
         </p:txBody>
@@ -4206,7 +4486,7 @@
                   <a:srgbClr val="1F3A5F"/>
                 </a:solidFill>
               </a:rPr>
-              <a:t>Likely questions — thresholds, windows &amp; claims</a:t>
+              <a:t>Likely questions — data quality &amp; persistence</a:t>
             </a:r>
           </a:p>
         </p:txBody>
@@ -4244,7 +4524,7 @@
                   <a:srgbClr val="1F3A5F"/>
                 </a:solidFill>
               </a:rPr>
-              <a:t>Q: Why 85th and 95th specifically — aren't those arbitrary?</a:t>
+              <a:t>Q: With ~13% of county-days imputed and 22 counties fully imputed, can I trust the maps?</a:t>
             </a:r>
           </a:p>
           <a:p>
@@ -4254,7 +4534,7 @@
                   <a:srgbClr val="555555"/>
                 </a:solidFill>
               </a:rPr>
-              <a:t>A: Conventional relative heat thresholds (95th has published precedent), chosen to bracket a moderate and a severe cut. A fuller threshold sweep is a reasonable extension.</a:t>
+              <a:t>A: Regionally yes, pixel-by-pixel no. Fully-imputed counties are interpolated, not observed — flag/exclude them for single-county claims. Statewide totals don't hinge on any one county.</a:t>
             </a:r>
           </a:p>
           <a:p>
@@ -4269,7 +4549,7 @@
                   <a:srgbClr val="1F3A5F"/>
                 </a:solidFill>
               </a:rPr>
-              <a:t>Q: A percentile fixes the exceedance rate — isn't the day count preordained?</a:t>
+              <a:t>Q: Is a 2-day exceedance really a 'wave', and is a 48-day event credible?</a:t>
             </a:r>
           </a:p>
           <a:p>
@@ -4279,7 +4559,7 @@
                   <a:srgbClr val="555555"/>
                 </a:solidFill>
               </a:rPr>
-              <a:t>A: The single-day rate is anchored (~15% / ~5%), but totals also depend on the &gt;=2-day rule and the walk-forward baseline. The informative content is WHERE and WHEN heat clusters, not the grand total.</a:t>
+              <a:t>A: The &gt;=2-day rule is a minimum-persistence filter; 44–53% of events are exactly 2 days, so 'elevated exposure' is fairer than 'wave' for much of it. Long tails are genuine persistent anomalies — lead with the median, not the max.</a:t>
             </a:r>
           </a:p>
           <a:p>
@@ -4294,7 +4574,7 @@
                   <a:srgbClr val="1F3A5F"/>
                 </a:solidFill>
               </a:rPr>
-              <a:t>Q: How sensitive are results to the 15-day window vs a calendar month?</a:t>
+              <a:t>Q: Some adjacent counties differ sharply — is that real climate?</a:t>
             </a:r>
           </a:p>
           <a:p>
@@ -4304,32 +4584,7 @@
                   <a:srgbClr val="555555"/>
                 </a:solidFill>
               </a:rPr>
-              <a:t>A: Not sensitive — the two windows agree at r≈0.99 per county. The consequential levers are the percentile and the floor/season choice.</a:t>
-            </a:r>
-          </a:p>
-          <a:p>
-            <a:pPr>
-              <a:spcBef>
-                <a:spcPts val="600"/>
-              </a:spcBef>
-            </a:pPr>
-            <a:r>
-              <a:rPr sz="1300" b="1">
-                <a:solidFill>
-                  <a:srgbClr val="1F3A5F"/>
-                </a:solidFill>
-              </a:rPr>
-              <a:t>Q: What can these results actually support?</a:t>
-            </a:r>
-          </a:p>
-          <a:p>
-            <a:r>
-              <a:rPr sz="1100">
-                <a:solidFill>
-                  <a:srgbClr val="555555"/>
-                </a:solidFill>
-              </a:rPr>
-              <a:t>A: County-level environmental apparent-heat EXPOSURE classification — not worker dose, causal injury, or official-advisory equivalence.</a:t>
+              <a:t>A: Largely no — it reflects the changing multi-station composite + IDW imputation, not micro-climate. That's why single-county rankings are presented cautiously.</a:t>
             </a:r>
           </a:p>
         </p:txBody>
@@ -4343,6 +4598,374 @@
 </file>
 
 <file path=ppt/slides/slide19.xml><?xml version="1.0" encoding="utf-8"?>
+<p:sld xmlns:a="http://schemas.openxmlformats.org/drawingml/2006/main" xmlns:p="http://schemas.openxmlformats.org/presentationml/2006/main" xmlns:r="http://schemas.openxmlformats.org/officeDocument/2006/relationships">
+  <p:cSld>
+    <p:spTree>
+      <p:nvGrpSpPr>
+        <p:cNvPr id="1" name=""/>
+        <p:cNvGrpSpPr/>
+        <p:nvPr/>
+      </p:nvGrpSpPr>
+      <p:grpSpPr/>
+      <p:sp>
+        <p:nvSpPr>
+          <p:cNvPr id="2" name="TextBox 1"/>
+          <p:cNvSpPr txBox="1"/>
+          <p:nvPr/>
+        </p:nvSpPr>
+        <p:spPr>
+          <a:xfrm>
+            <a:off x="457200" y="228600"/>
+            <a:ext cx="11247120" cy="914400"/>
+          </a:xfrm>
+          <a:prstGeom prst="rect">
+            <a:avLst/>
+          </a:prstGeom>
+          <a:noFill/>
+        </p:spPr>
+        <p:txBody>
+          <a:bodyPr wrap="square">
+            <a:spAutoFit/>
+          </a:bodyPr>
+          <a:lstStyle/>
+          <a:p>
+            <a:r>
+              <a:rPr sz="2400" b="1">
+                <a:solidFill>
+                  <a:srgbClr val="1F3A5F"/>
+                </a:solidFill>
+              </a:rPr>
+              <a:t>Likely questions — thresholds, windows &amp; claims</a:t>
+            </a:r>
+          </a:p>
+        </p:txBody>
+      </p:sp>
+      <p:sp>
+        <p:nvSpPr>
+          <p:cNvPr id="3" name="TextBox 2"/>
+          <p:cNvSpPr txBox="1"/>
+          <p:nvPr/>
+        </p:nvSpPr>
+        <p:spPr>
+          <a:xfrm>
+            <a:off x="548640" y="1325880"/>
+            <a:ext cx="11064240" cy="5029200"/>
+          </a:xfrm>
+          <a:prstGeom prst="rect">
+            <a:avLst/>
+          </a:prstGeom>
+          <a:noFill/>
+        </p:spPr>
+        <p:txBody>
+          <a:bodyPr wrap="square">
+            <a:spAutoFit/>
+          </a:bodyPr>
+          <a:lstStyle/>
+          <a:p>
+            <a:pPr>
+              <a:spcBef>
+                <a:spcPts val="600"/>
+              </a:spcBef>
+            </a:pPr>
+            <a:r>
+              <a:rPr sz="1300" b="1">
+                <a:solidFill>
+                  <a:srgbClr val="1F3A5F"/>
+                </a:solidFill>
+              </a:rPr>
+              <a:t>Q: Why 85th and 95th specifically — aren't those arbitrary?</a:t>
+            </a:r>
+          </a:p>
+          <a:p>
+            <a:r>
+              <a:rPr sz="1100">
+                <a:solidFill>
+                  <a:srgbClr val="555555"/>
+                </a:solidFill>
+              </a:rPr>
+              <a:t>A: Conventional relative heat thresholds (95th has published precedent), chosen to bracket a moderate and a severe cut. A fuller threshold sweep is a reasonable extension.</a:t>
+            </a:r>
+          </a:p>
+          <a:p>
+            <a:pPr>
+              <a:spcBef>
+                <a:spcPts val="600"/>
+              </a:spcBef>
+            </a:pPr>
+            <a:r>
+              <a:rPr sz="1300" b="1">
+                <a:solidFill>
+                  <a:srgbClr val="1F3A5F"/>
+                </a:solidFill>
+              </a:rPr>
+              <a:t>Q: A percentile fixes the exceedance rate — isn't the day count preordained?</a:t>
+            </a:r>
+          </a:p>
+          <a:p>
+            <a:r>
+              <a:rPr sz="1100">
+                <a:solidFill>
+                  <a:srgbClr val="555555"/>
+                </a:solidFill>
+              </a:rPr>
+              <a:t>A: The single-day rate is anchored (~15% / ~5%), but totals also depend on the &gt;=2-day rule and the walk-forward baseline. The informative content is WHERE and WHEN heat clusters, not the grand total.</a:t>
+            </a:r>
+          </a:p>
+          <a:p>
+            <a:pPr>
+              <a:spcBef>
+                <a:spcPts val="600"/>
+              </a:spcBef>
+            </a:pPr>
+            <a:r>
+              <a:rPr sz="1300" b="1">
+                <a:solidFill>
+                  <a:srgbClr val="1F3A5F"/>
+                </a:solidFill>
+              </a:rPr>
+              <a:t>Q: How sensitive are results to the 15-day window vs a calendar month?</a:t>
+            </a:r>
+          </a:p>
+          <a:p>
+            <a:r>
+              <a:rPr sz="1100">
+                <a:solidFill>
+                  <a:srgbClr val="555555"/>
+                </a:solidFill>
+              </a:rPr>
+              <a:t>A: Not sensitive — the two windows agree at r≈0.99 per county. The consequential levers are the percentile and the floor/season choice.</a:t>
+            </a:r>
+          </a:p>
+          <a:p>
+            <a:pPr>
+              <a:spcBef>
+                <a:spcPts val="600"/>
+              </a:spcBef>
+            </a:pPr>
+            <a:r>
+              <a:rPr sz="1300" b="1">
+                <a:solidFill>
+                  <a:srgbClr val="1F3A5F"/>
+                </a:solidFill>
+              </a:rPr>
+              <a:t>Q: What can these results actually support?</a:t>
+            </a:r>
+          </a:p>
+          <a:p>
+            <a:r>
+              <a:rPr sz="1100">
+                <a:solidFill>
+                  <a:srgbClr val="555555"/>
+                </a:solidFill>
+              </a:rPr>
+              <a:t>A: County-level environmental apparent-heat EXPOSURE classification — not worker dose, causal injury, or official-advisory equivalence.</a:t>
+            </a:r>
+          </a:p>
+        </p:txBody>
+      </p:sp>
+    </p:spTree>
+  </p:cSld>
+  <p:clrMapOvr>
+    <a:masterClrMapping/>
+  </p:clrMapOvr>
+</p:sld>
+</file>
+
+<file path=ppt/slides/slide2.xml><?xml version="1.0" encoding="utf-8"?>
+<p:sld xmlns:a="http://schemas.openxmlformats.org/drawingml/2006/main" xmlns:p="http://schemas.openxmlformats.org/presentationml/2006/main" xmlns:r="http://schemas.openxmlformats.org/officeDocument/2006/relationships">
+  <p:cSld>
+    <p:spTree>
+      <p:nvGrpSpPr>
+        <p:cNvPr id="1" name=""/>
+        <p:cNvGrpSpPr/>
+        <p:nvPr/>
+      </p:nvGrpSpPr>
+      <p:grpSpPr/>
+      <p:sp>
+        <p:nvSpPr>
+          <p:cNvPr id="2" name="TextBox 1"/>
+          <p:cNvSpPr txBox="1"/>
+          <p:nvPr/>
+        </p:nvSpPr>
+        <p:spPr>
+          <a:xfrm>
+            <a:off x="457200" y="228600"/>
+            <a:ext cx="11247120" cy="914400"/>
+          </a:xfrm>
+          <a:prstGeom prst="rect">
+            <a:avLst/>
+          </a:prstGeom>
+          <a:noFill/>
+        </p:spPr>
+        <p:txBody>
+          <a:bodyPr wrap="square">
+            <a:spAutoFit/>
+          </a:bodyPr>
+          <a:lstStyle/>
+          <a:p>
+            <a:r>
+              <a:rPr sz="2400" b="1">
+                <a:solidFill>
+                  <a:srgbClr val="1F3A5F"/>
+                </a:solidFill>
+              </a:rPr>
+              <a:t>What we are presenting</a:t>
+            </a:r>
+          </a:p>
+        </p:txBody>
+      </p:sp>
+      <p:sp>
+        <p:nvSpPr>
+          <p:cNvPr id="3" name="TextBox 2"/>
+          <p:cNvSpPr txBox="1"/>
+          <p:nvPr/>
+        </p:nvSpPr>
+        <p:spPr>
+          <a:xfrm>
+            <a:off x="548640" y="1325880"/>
+            <a:ext cx="11064240" cy="4937760"/>
+          </a:xfrm>
+          <a:prstGeom prst="rect">
+            <a:avLst/>
+          </a:prstGeom>
+          <a:noFill/>
+        </p:spPr>
+        <p:txBody>
+          <a:bodyPr wrap="square">
+            <a:spAutoFit/>
+          </a:bodyPr>
+          <a:lstStyle/>
+          <a:p>
+            <a:pPr>
+              <a:spcAft>
+                <a:spcPts val="500"/>
+              </a:spcAft>
+            </a:pPr>
+            <a:r>
+              <a:rPr sz="1400" b="1">
+                <a:solidFill>
+                  <a:srgbClr val="1F3A5F"/>
+                </a:solidFill>
+              </a:rPr>
+              <a:t>• Two heatwave definitions, each shown on its own (not compared head-to-head):</a:t>
+            </a:r>
+          </a:p>
+          <a:p>
+            <a:pPr lvl="1">
+              <a:spcAft>
+                <a:spcPts val="500"/>
+              </a:spcAft>
+            </a:pPr>
+            <a:r>
+              <a:rPr sz="1200" b="0">
+                <a:solidFill>
+                  <a:srgbClr val="555555"/>
+                </a:solidFill>
+              </a:rPr>
+              <a:t>   – Definition 01 — county-relative 85th-percentile daily-mean heat index, &gt;=2 consecutive days, walk-forward baseline</a:t>
+            </a:r>
+          </a:p>
+          <a:p>
+            <a:pPr lvl="1">
+              <a:spcAft>
+                <a:spcPts val="500"/>
+              </a:spcAft>
+            </a:pPr>
+            <a:r>
+              <a:rPr sz="1200" b="0">
+                <a:solidFill>
+                  <a:srgbClr val="555555"/>
+                </a:solidFill>
+              </a:rPr>
+              <a:t>   – Definition 02 — same, at the 95th percentile</a:t>
+            </a:r>
+          </a:p>
+          <a:p>
+            <a:pPr>
+              <a:spcAft>
+                <a:spcPts val="500"/>
+              </a:spcAft>
+            </a:pPr>
+            <a:r>
+              <a:rPr sz="1400" b="1">
+                <a:solidFill>
+                  <a:srgbClr val="1F3A5F"/>
+                </a:solidFill>
+              </a:rPr>
+              <a:t>• Unit of analysis:</a:t>
+            </a:r>
+          </a:p>
+          <a:p>
+            <a:pPr lvl="1">
+              <a:spcAft>
+                <a:spcPts val="500"/>
+              </a:spcAft>
+            </a:pPr>
+            <a:r>
+              <a:rPr sz="1200" b="0">
+                <a:solidFill>
+                  <a:srgbClr val="555555"/>
+                </a:solidFill>
+              </a:rPr>
+              <a:t>   – heatwave DAY = one county on one date inside a &gt;=2-day run</a:t>
+            </a:r>
+          </a:p>
+          <a:p>
+            <a:pPr lvl="1">
+              <a:spcAft>
+                <a:spcPts val="500"/>
+              </a:spcAft>
+            </a:pPr>
+            <a:r>
+              <a:rPr sz="1200" b="0">
+                <a:solidFill>
+                  <a:srgbClr val="555555"/>
+                </a:solidFill>
+              </a:rPr>
+              <a:t>   – heatwave EVENT = one uninterrupted run of heatwave days in one county; duration = its length in days</a:t>
+            </a:r>
+          </a:p>
+          <a:p>
+            <a:pPr>
+              <a:spcAft>
+                <a:spcPts val="500"/>
+              </a:spcAft>
+            </a:pPr>
+            <a:r>
+              <a:rPr sz="1400" b="1">
+                <a:solidFill>
+                  <a:srgbClr val="1F3A5F"/>
+                </a:solidFill>
+              </a:rPr>
+              <a:t>• Both are YEAR-ROUND, COUNTY-RELATIVE ('unusually hot for this county &amp; date') = a persistent apparent-heat anomaly</a:t>
+            </a:r>
+          </a:p>
+          <a:p>
+            <a:pPr>
+              <a:spcAft>
+                <a:spcPts val="500"/>
+              </a:spcAft>
+            </a:pPr>
+            <a:r>
+              <a:rPr sz="1400" b="0">
+                <a:solidFill>
+                  <a:srgbClr val="1F3A5F"/>
+                </a:solidFill>
+              </a:rPr>
+              <a:t>• For each definition: results from the CSVs -&gt; figures -&gt; what they mean; then likely questions; then caveats.</a:t>
+            </a:r>
+          </a:p>
+        </p:txBody>
+      </p:sp>
+    </p:spTree>
+  </p:cSld>
+  <p:clrMapOvr>
+    <a:masterClrMapping/>
+  </p:clrMapOvr>
+</p:sld>
+</file>
+
+<file path=ppt/slides/slide20.xml><?xml version="1.0" encoding="utf-8"?>
 <p:sld xmlns:a="http://schemas.openxmlformats.org/drawingml/2006/main" xmlns:p="http://schemas.openxmlformats.org/presentationml/2006/main" xmlns:r="http://schemas.openxmlformats.org/officeDocument/2006/relationships">
   <p:cSld>
     <p:spTree>
@@ -4411,201 +5034,7 @@
 </p:sld>
 </file>
 
-<file path=ppt/slides/slide2.xml><?xml version="1.0" encoding="utf-8"?>
-<p:sld xmlns:a="http://schemas.openxmlformats.org/drawingml/2006/main" xmlns:p="http://schemas.openxmlformats.org/presentationml/2006/main" xmlns:r="http://schemas.openxmlformats.org/officeDocument/2006/relationships">
-  <p:cSld>
-    <p:spTree>
-      <p:nvGrpSpPr>
-        <p:cNvPr id="1" name=""/>
-        <p:cNvGrpSpPr/>
-        <p:nvPr/>
-      </p:nvGrpSpPr>
-      <p:grpSpPr/>
-      <p:sp>
-        <p:nvSpPr>
-          <p:cNvPr id="2" name="TextBox 1"/>
-          <p:cNvSpPr txBox="1"/>
-          <p:nvPr/>
-        </p:nvSpPr>
-        <p:spPr>
-          <a:xfrm>
-            <a:off x="457200" y="228600"/>
-            <a:ext cx="11247120" cy="914400"/>
-          </a:xfrm>
-          <a:prstGeom prst="rect">
-            <a:avLst/>
-          </a:prstGeom>
-          <a:noFill/>
-        </p:spPr>
-        <p:txBody>
-          <a:bodyPr wrap="square">
-            <a:spAutoFit/>
-          </a:bodyPr>
-          <a:lstStyle/>
-          <a:p>
-            <a:r>
-              <a:rPr sz="2400" b="1">
-                <a:solidFill>
-                  <a:srgbClr val="1F3A5F"/>
-                </a:solidFill>
-              </a:rPr>
-              <a:t>What we are presenting</a:t>
-            </a:r>
-          </a:p>
-        </p:txBody>
-      </p:sp>
-      <p:sp>
-        <p:nvSpPr>
-          <p:cNvPr id="3" name="TextBox 2"/>
-          <p:cNvSpPr txBox="1"/>
-          <p:nvPr/>
-        </p:nvSpPr>
-        <p:spPr>
-          <a:xfrm>
-            <a:off x="548640" y="1325880"/>
-            <a:ext cx="11064240" cy="4937760"/>
-          </a:xfrm>
-          <a:prstGeom prst="rect">
-            <a:avLst/>
-          </a:prstGeom>
-          <a:noFill/>
-        </p:spPr>
-        <p:txBody>
-          <a:bodyPr wrap="square">
-            <a:spAutoFit/>
-          </a:bodyPr>
-          <a:lstStyle/>
-          <a:p>
-            <a:pPr>
-              <a:spcAft>
-                <a:spcPts val="500"/>
-              </a:spcAft>
-            </a:pPr>
-            <a:r>
-              <a:rPr sz="1400" b="1">
-                <a:solidFill>
-                  <a:srgbClr val="1F3A5F"/>
-                </a:solidFill>
-              </a:rPr>
-              <a:t>• Two heatwave definitions, each shown on its own (not compared head-to-head):</a:t>
-            </a:r>
-          </a:p>
-          <a:p>
-            <a:pPr lvl="1">
-              <a:spcAft>
-                <a:spcPts val="500"/>
-              </a:spcAft>
-            </a:pPr>
-            <a:r>
-              <a:rPr sz="1200" b="0">
-                <a:solidFill>
-                  <a:srgbClr val="555555"/>
-                </a:solidFill>
-              </a:rPr>
-              <a:t>   – Definition 01 — county-relative 85th-percentile daily-mean heat index, &gt;=2 consecutive days, walk-forward baseline</a:t>
-            </a:r>
-          </a:p>
-          <a:p>
-            <a:pPr lvl="1">
-              <a:spcAft>
-                <a:spcPts val="500"/>
-              </a:spcAft>
-            </a:pPr>
-            <a:r>
-              <a:rPr sz="1200" b="0">
-                <a:solidFill>
-                  <a:srgbClr val="555555"/>
-                </a:solidFill>
-              </a:rPr>
-              <a:t>   – Definition 02 — same, at the 95th percentile</a:t>
-            </a:r>
-          </a:p>
-          <a:p>
-            <a:pPr>
-              <a:spcAft>
-                <a:spcPts val="500"/>
-              </a:spcAft>
-            </a:pPr>
-            <a:r>
-              <a:rPr sz="1400" b="1">
-                <a:solidFill>
-                  <a:srgbClr val="1F3A5F"/>
-                </a:solidFill>
-              </a:rPr>
-              <a:t>• Unit of analysis:</a:t>
-            </a:r>
-          </a:p>
-          <a:p>
-            <a:pPr lvl="1">
-              <a:spcAft>
-                <a:spcPts val="500"/>
-              </a:spcAft>
-            </a:pPr>
-            <a:r>
-              <a:rPr sz="1200" b="0">
-                <a:solidFill>
-                  <a:srgbClr val="555555"/>
-                </a:solidFill>
-              </a:rPr>
-              <a:t>   – heatwave DAY = one county on one date inside a &gt;=2-day run</a:t>
-            </a:r>
-          </a:p>
-          <a:p>
-            <a:pPr lvl="1">
-              <a:spcAft>
-                <a:spcPts val="500"/>
-              </a:spcAft>
-            </a:pPr>
-            <a:r>
-              <a:rPr sz="1200" b="0">
-                <a:solidFill>
-                  <a:srgbClr val="555555"/>
-                </a:solidFill>
-              </a:rPr>
-              <a:t>   – heatwave EVENT = one uninterrupted run of heatwave days in one county; duration = its length in days</a:t>
-            </a:r>
-          </a:p>
-          <a:p>
-            <a:pPr>
-              <a:spcAft>
-                <a:spcPts val="500"/>
-              </a:spcAft>
-            </a:pPr>
-            <a:r>
-              <a:rPr sz="1400" b="1">
-                <a:solidFill>
-                  <a:srgbClr val="1F3A5F"/>
-                </a:solidFill>
-              </a:rPr>
-              <a:t>• Both are YEAR-ROUND, COUNTY-RELATIVE ('unusually hot for this county &amp; date') = a persistent apparent-heat anomaly</a:t>
-            </a:r>
-          </a:p>
-          <a:p>
-            <a:pPr>
-              <a:spcAft>
-                <a:spcPts val="500"/>
-              </a:spcAft>
-            </a:pPr>
-            <a:r>
-              <a:rPr sz="1400" b="0">
-                <a:solidFill>
-                  <a:srgbClr val="1F3A5F"/>
-                </a:solidFill>
-              </a:rPr>
-              <a:t>• For each definition: results from the CSVs -&gt; figures -&gt; what they mean; then likely questions; then caveats.</a:t>
-            </a:r>
-          </a:p>
-        </p:txBody>
-      </p:sp>
-    </p:spTree>
-  </p:cSld>
-  <p:clrMapOvr>
-    <a:masterClrMapping/>
-  </p:clrMapOvr>
-</p:sld>
-</file>
-
-<file path=ppt/slides/slide20.xml><?xml version="1.0" encoding="utf-8"?>
+<file path=ppt/slides/slide21.xml><?xml version="1.0" encoding="utf-8"?>
 <p:sld xmlns:a="http://schemas.openxmlformats.org/drawingml/2006/main" xmlns:p="http://schemas.openxmlformats.org/presentationml/2006/main" xmlns:r="http://schemas.openxmlformats.org/officeDocument/2006/relationships">
   <p:cSld>
     <p:spTree>

</xml_diff>

<commit_message>
Add calendar-month threshold-window FIGURES for both definitions
- Month-window figures (choropleth, seasonal, event-duration, annual, top-counties)
  generated for Def01 & Def02, saved with _month suffix in each def's figures/.
- Results deck: added month choropleth + seasonal slides per definition (now 25 slides).
- RESULTS_PRESENTATION.md notes the month figures.
Previously only the numbers (not figures) existed for the month window.

Co-Authored-By: Claude Opus 4.8 <noreply@anthropic.com>
</commit_message>
<xml_diff>
--- a/reference/Heatwave_Results_Deck.pptx
+++ b/reference/Heatwave_Results_Deck.pptx
@@ -26,6 +26,10 @@
     <p:sldId id="274" r:id="rId25"/>
     <p:sldId id="275" r:id="rId26"/>
     <p:sldId id="276" r:id="rId27"/>
+    <p:sldId id="277" r:id="rId28"/>
+    <p:sldId id="278" r:id="rId29"/>
+    <p:sldId id="279" r:id="rId30"/>
+    <p:sldId id="280" r:id="rId31"/>
   </p:sldIdLst>
   <p:sldSz cx="12191695" cy="6858000" type="screen4x3"/>
   <p:notesSz cx="6858000" cy="9144000"/>
@@ -3555,6 +3559,438 @@
 </file>
 
 <file path=ppt/slides/slide13.xml><?xml version="1.0" encoding="utf-8"?>
+<p:sld xmlns:a="http://schemas.openxmlformats.org/drawingml/2006/main" xmlns:p="http://schemas.openxmlformats.org/presentationml/2006/main" xmlns:r="http://schemas.openxmlformats.org/officeDocument/2006/relationships">
+  <p:cSld>
+    <p:spTree>
+      <p:nvGrpSpPr>
+        <p:cNvPr id="1" name=""/>
+        <p:cNvGrpSpPr/>
+        <p:nvPr/>
+      </p:nvGrpSpPr>
+      <p:grpSpPr/>
+      <p:sp>
+        <p:nvSpPr>
+          <p:cNvPr id="2" name="TextBox 1"/>
+          <p:cNvSpPr txBox="1"/>
+          <p:nvPr/>
+        </p:nvSpPr>
+        <p:spPr>
+          <a:xfrm>
+            <a:off x="457200" y="228600"/>
+            <a:ext cx="11247120" cy="914400"/>
+          </a:xfrm>
+          <a:prstGeom prst="rect">
+            <a:avLst/>
+          </a:prstGeom>
+          <a:noFill/>
+        </p:spPr>
+        <p:txBody>
+          <a:bodyPr wrap="square">
+            <a:spAutoFit/>
+          </a:bodyPr>
+          <a:lstStyle/>
+          <a:p>
+            <a:r>
+              <a:rPr sz="2400" b="1">
+                <a:solidFill>
+                  <a:srgbClr val="4C72B0"/>
+                </a:solidFill>
+              </a:rPr>
+              <a:t>Def 01 — heatwave days per county [calendar-month window]</a:t>
+            </a:r>
+          </a:p>
+        </p:txBody>
+      </p:sp>
+      <p:pic>
+        <p:nvPicPr>
+          <p:cNvPr id="3" name="Picture 2" descr="map01_heatwave_days_per_county_month.png"/>
+          <p:cNvPicPr>
+            <a:picLocks noChangeAspect="1"/>
+          </p:cNvPicPr>
+          <p:nvPr/>
+        </p:nvPicPr>
+        <p:blipFill>
+          <a:blip r:embed="rId2"/>
+          <a:stretch>
+            <a:fillRect/>
+          </a:stretch>
+        </p:blipFill>
+        <p:spPr>
+          <a:xfrm>
+            <a:off x="3552656" y="1325880"/>
+            <a:ext cx="5086382" cy="4480560"/>
+          </a:xfrm>
+          <a:prstGeom prst="rect">
+            <a:avLst/>
+          </a:prstGeom>
+        </p:spPr>
+      </p:pic>
+      <p:sp>
+        <p:nvSpPr>
+          <p:cNvPr id="4" name="TextBox 3"/>
+          <p:cNvSpPr txBox="1"/>
+          <p:nvPr/>
+        </p:nvSpPr>
+        <p:spPr>
+          <a:xfrm>
+            <a:off x="548640" y="5943600"/>
+            <a:ext cx="11064240" cy="640080"/>
+          </a:xfrm>
+          <a:prstGeom prst="rect">
+            <a:avLst/>
+          </a:prstGeom>
+          <a:noFill/>
+        </p:spPr>
+        <p:txBody>
+          <a:bodyPr wrap="square">
+            <a:spAutoFit/>
+          </a:bodyPr>
+          <a:lstStyle/>
+          <a:p>
+            <a:r>
+              <a:rPr sz="1200" i="1">
+                <a:solidFill>
+                  <a:srgbClr val="555555"/>
+                </a:solidFill>
+              </a:rPr>
+              <a:t>Robustness: the calendar-month threshold gives essentially the same map as the 15-day window (per-county r=0.994).</a:t>
+            </a:r>
+          </a:p>
+        </p:txBody>
+      </p:sp>
+    </p:spTree>
+  </p:cSld>
+  <p:clrMapOvr>
+    <a:masterClrMapping/>
+  </p:clrMapOvr>
+</p:sld>
+</file>
+
+<file path=ppt/slides/slide14.xml><?xml version="1.0" encoding="utf-8"?>
+<p:sld xmlns:a="http://schemas.openxmlformats.org/drawingml/2006/main" xmlns:p="http://schemas.openxmlformats.org/presentationml/2006/main" xmlns:r="http://schemas.openxmlformats.org/officeDocument/2006/relationships">
+  <p:cSld>
+    <p:spTree>
+      <p:nvGrpSpPr>
+        <p:cNvPr id="1" name=""/>
+        <p:cNvGrpSpPr/>
+        <p:nvPr/>
+      </p:nvGrpSpPr>
+      <p:grpSpPr/>
+      <p:sp>
+        <p:nvSpPr>
+          <p:cNvPr id="2" name="TextBox 1"/>
+          <p:cNvSpPr txBox="1"/>
+          <p:nvPr/>
+        </p:nvSpPr>
+        <p:spPr>
+          <a:xfrm>
+            <a:off x="457200" y="228600"/>
+            <a:ext cx="11247120" cy="914400"/>
+          </a:xfrm>
+          <a:prstGeom prst="rect">
+            <a:avLst/>
+          </a:prstGeom>
+          <a:noFill/>
+        </p:spPr>
+        <p:txBody>
+          <a:bodyPr wrap="square">
+            <a:spAutoFit/>
+          </a:bodyPr>
+          <a:lstStyle/>
+          <a:p>
+            <a:r>
+              <a:rPr sz="2400" b="1">
+                <a:solidFill>
+                  <a:srgbClr val="4C72B0"/>
+                </a:solidFill>
+              </a:rPr>
+              <a:t>Def 01 — seasonal share [calendar-month window]</a:t>
+            </a:r>
+          </a:p>
+        </p:txBody>
+      </p:sp>
+      <p:pic>
+        <p:nvPicPr>
+          <p:cNvPr id="3" name="Picture 2" descr="res_seasonal_month.png"/>
+          <p:cNvPicPr>
+            <a:picLocks noChangeAspect="1"/>
+          </p:cNvPicPr>
+          <p:nvPr/>
+        </p:nvPicPr>
+        <p:blipFill>
+          <a:blip r:embed="rId2"/>
+          <a:stretch>
+            <a:fillRect/>
+          </a:stretch>
+        </p:blipFill>
+        <p:spPr>
+          <a:xfrm>
+            <a:off x="1758739" y="1325880"/>
+            <a:ext cx="8674217" cy="4480560"/>
+          </a:xfrm>
+          <a:prstGeom prst="rect">
+            <a:avLst/>
+          </a:prstGeom>
+        </p:spPr>
+      </p:pic>
+      <p:sp>
+        <p:nvSpPr>
+          <p:cNvPr id="4" name="TextBox 3"/>
+          <p:cNvSpPr txBox="1"/>
+          <p:nvPr/>
+        </p:nvSpPr>
+        <p:spPr>
+          <a:xfrm>
+            <a:off x="548640" y="5943600"/>
+            <a:ext cx="11064240" cy="640080"/>
+          </a:xfrm>
+          <a:prstGeom prst="rect">
+            <a:avLst/>
+          </a:prstGeom>
+          <a:noFill/>
+        </p:spPr>
+        <p:txBody>
+          <a:bodyPr wrap="square">
+            <a:spAutoFit/>
+          </a:bodyPr>
+          <a:lstStyle/>
+          <a:p>
+            <a:r>
+              <a:rPr sz="1200" i="1">
+                <a:solidFill>
+                  <a:srgbClr val="555555"/>
+                </a:solidFill>
+              </a:rPr>
+              <a:t>Same seasonal pattern as the 15-day window (~37% of heatwave days in Jun-Sep).</a:t>
+            </a:r>
+          </a:p>
+        </p:txBody>
+      </p:sp>
+    </p:spTree>
+  </p:cSld>
+  <p:clrMapOvr>
+    <a:masterClrMapping/>
+  </p:clrMapOvr>
+</p:sld>
+</file>
+
+<file path=ppt/slides/slide15.xml><?xml version="1.0" encoding="utf-8"?>
+<p:sld xmlns:a="http://schemas.openxmlformats.org/drawingml/2006/main" xmlns:p="http://schemas.openxmlformats.org/presentationml/2006/main" xmlns:r="http://schemas.openxmlformats.org/officeDocument/2006/relationships">
+  <p:cSld>
+    <p:spTree>
+      <p:nvGrpSpPr>
+        <p:cNvPr id="1" name=""/>
+        <p:cNvGrpSpPr/>
+        <p:nvPr/>
+      </p:nvGrpSpPr>
+      <p:grpSpPr/>
+      <p:sp>
+        <p:nvSpPr>
+          <p:cNvPr id="2" name="TextBox 1"/>
+          <p:cNvSpPr txBox="1"/>
+          <p:nvPr/>
+        </p:nvSpPr>
+        <p:spPr>
+          <a:xfrm>
+            <a:off x="457200" y="228600"/>
+            <a:ext cx="11247120" cy="914400"/>
+          </a:xfrm>
+          <a:prstGeom prst="rect">
+            <a:avLst/>
+          </a:prstGeom>
+          <a:noFill/>
+        </p:spPr>
+        <p:txBody>
+          <a:bodyPr wrap="square">
+            <a:spAutoFit/>
+          </a:bodyPr>
+          <a:lstStyle/>
+          <a:p>
+            <a:r>
+              <a:rPr sz="2400" b="1">
+                <a:solidFill>
+                  <a:srgbClr val="C44E52"/>
+                </a:solidFill>
+              </a:rPr>
+              <a:t>Def 02 — heatwave days per county [calendar-month window]</a:t>
+            </a:r>
+          </a:p>
+        </p:txBody>
+      </p:sp>
+      <p:pic>
+        <p:nvPicPr>
+          <p:cNvPr id="3" name="Picture 2" descr="map01_heatwave_days_per_county_month.png"/>
+          <p:cNvPicPr>
+            <a:picLocks noChangeAspect="1"/>
+          </p:cNvPicPr>
+          <p:nvPr/>
+        </p:nvPicPr>
+        <p:blipFill>
+          <a:blip r:embed="rId2"/>
+          <a:stretch>
+            <a:fillRect/>
+          </a:stretch>
+        </p:blipFill>
+        <p:spPr>
+          <a:xfrm>
+            <a:off x="3573692" y="1325880"/>
+            <a:ext cx="5044311" cy="4480560"/>
+          </a:xfrm>
+          <a:prstGeom prst="rect">
+            <a:avLst/>
+          </a:prstGeom>
+        </p:spPr>
+      </p:pic>
+      <p:sp>
+        <p:nvSpPr>
+          <p:cNvPr id="4" name="TextBox 3"/>
+          <p:cNvSpPr txBox="1"/>
+          <p:nvPr/>
+        </p:nvSpPr>
+        <p:spPr>
+          <a:xfrm>
+            <a:off x="548640" y="5943600"/>
+            <a:ext cx="11064240" cy="640080"/>
+          </a:xfrm>
+          <a:prstGeom prst="rect">
+            <a:avLst/>
+          </a:prstGeom>
+          <a:noFill/>
+        </p:spPr>
+        <p:txBody>
+          <a:bodyPr wrap="square">
+            <a:spAutoFit/>
+          </a:bodyPr>
+          <a:lstStyle/>
+          <a:p>
+            <a:r>
+              <a:rPr sz="1200" i="1">
+                <a:solidFill>
+                  <a:srgbClr val="555555"/>
+                </a:solidFill>
+              </a:rPr>
+              <a:t>Robustness: near-identical to the 15-day window (per-county r=0.987).</a:t>
+            </a:r>
+          </a:p>
+        </p:txBody>
+      </p:sp>
+    </p:spTree>
+  </p:cSld>
+  <p:clrMapOvr>
+    <a:masterClrMapping/>
+  </p:clrMapOvr>
+</p:sld>
+</file>
+
+<file path=ppt/slides/slide16.xml><?xml version="1.0" encoding="utf-8"?>
+<p:sld xmlns:a="http://schemas.openxmlformats.org/drawingml/2006/main" xmlns:p="http://schemas.openxmlformats.org/presentationml/2006/main" xmlns:r="http://schemas.openxmlformats.org/officeDocument/2006/relationships">
+  <p:cSld>
+    <p:spTree>
+      <p:nvGrpSpPr>
+        <p:cNvPr id="1" name=""/>
+        <p:cNvGrpSpPr/>
+        <p:nvPr/>
+      </p:nvGrpSpPr>
+      <p:grpSpPr/>
+      <p:sp>
+        <p:nvSpPr>
+          <p:cNvPr id="2" name="TextBox 1"/>
+          <p:cNvSpPr txBox="1"/>
+          <p:nvPr/>
+        </p:nvSpPr>
+        <p:spPr>
+          <a:xfrm>
+            <a:off x="457200" y="228600"/>
+            <a:ext cx="11247120" cy="914400"/>
+          </a:xfrm>
+          <a:prstGeom prst="rect">
+            <a:avLst/>
+          </a:prstGeom>
+          <a:noFill/>
+        </p:spPr>
+        <p:txBody>
+          <a:bodyPr wrap="square">
+            <a:spAutoFit/>
+          </a:bodyPr>
+          <a:lstStyle/>
+          <a:p>
+            <a:r>
+              <a:rPr sz="2400" b="1">
+                <a:solidFill>
+                  <a:srgbClr val="C44E52"/>
+                </a:solidFill>
+              </a:rPr>
+              <a:t>Def 02 — seasonal share [calendar-month window]</a:t>
+            </a:r>
+          </a:p>
+        </p:txBody>
+      </p:sp>
+      <p:pic>
+        <p:nvPicPr>
+          <p:cNvPr id="3" name="Picture 2" descr="res_seasonal_month.png"/>
+          <p:cNvPicPr>
+            <a:picLocks noChangeAspect="1"/>
+          </p:cNvPicPr>
+          <p:nvPr/>
+        </p:nvPicPr>
+        <p:blipFill>
+          <a:blip r:embed="rId2"/>
+          <a:stretch>
+            <a:fillRect/>
+          </a:stretch>
+        </p:blipFill>
+        <p:spPr>
+          <a:xfrm>
+            <a:off x="1758739" y="1325880"/>
+            <a:ext cx="8674217" cy="4480560"/>
+          </a:xfrm>
+          <a:prstGeom prst="rect">
+            <a:avLst/>
+          </a:prstGeom>
+        </p:spPr>
+      </p:pic>
+      <p:sp>
+        <p:nvSpPr>
+          <p:cNvPr id="4" name="TextBox 3"/>
+          <p:cNvSpPr txBox="1"/>
+          <p:nvPr/>
+        </p:nvSpPr>
+        <p:spPr>
+          <a:xfrm>
+            <a:off x="548640" y="5943600"/>
+            <a:ext cx="11064240" cy="640080"/>
+          </a:xfrm>
+          <a:prstGeom prst="rect">
+            <a:avLst/>
+          </a:prstGeom>
+          <a:noFill/>
+        </p:spPr>
+        <p:txBody>
+          <a:bodyPr wrap="square">
+            <a:spAutoFit/>
+          </a:bodyPr>
+          <a:lstStyle/>
+          <a:p>
+            <a:r>
+              <a:rPr sz="1200" i="1">
+                <a:solidFill>
+                  <a:srgbClr val="555555"/>
+                </a:solidFill>
+              </a:rPr>
+              <a:t>Same seasonal pattern as the 15-day window (~36% of heatwave days in Jun-Sep).</a:t>
+            </a:r>
+          </a:p>
+        </p:txBody>
+      </p:sp>
+    </p:spTree>
+  </p:cSld>
+  <p:clrMapOvr>
+    <a:masterClrMapping/>
+  </p:clrMapOvr>
+</p:sld>
+</file>
+
+<file path=ppt/slides/slide17.xml><?xml version="1.0" encoding="utf-8"?>
 <p:sld xmlns:a="http://schemas.openxmlformats.org/drawingml/2006/main" xmlns:p="http://schemas.openxmlformats.org/presentationml/2006/main" xmlns:r="http://schemas.openxmlformats.org/officeDocument/2006/relationships">
   <p:cSld>
     <p:spTree>
@@ -3982,7 +4418,7 @@
 </p:sld>
 </file>
 
-<file path=ppt/slides/slide14.xml><?xml version="1.0" encoding="utf-8"?>
+<file path=ppt/slides/slide18.xml><?xml version="1.0" encoding="utf-8"?>
 <p:sld xmlns:a="http://schemas.openxmlformats.org/drawingml/2006/main" xmlns:p="http://schemas.openxmlformats.org/presentationml/2006/main" xmlns:r="http://schemas.openxmlformats.org/officeDocument/2006/relationships">
   <p:cSld>
     <p:spTree>
@@ -4039,552 +4475,6 @@
                 </a:solidFill>
               </a:rPr>
               <a:t>Companion outputs (definition-independent)</a:t>
-            </a:r>
-          </a:p>
-        </p:txBody>
-      </p:sp>
-    </p:spTree>
-  </p:cSld>
-  <p:clrMapOvr>
-    <a:masterClrMapping/>
-  </p:clrMapOvr>
-</p:sld>
-</file>
-
-<file path=ppt/slides/slide15.xml><?xml version="1.0" encoding="utf-8"?>
-<p:sld xmlns:a="http://schemas.openxmlformats.org/drawingml/2006/main" xmlns:p="http://schemas.openxmlformats.org/presentationml/2006/main" xmlns:r="http://schemas.openxmlformats.org/officeDocument/2006/relationships">
-  <p:cSld>
-    <p:spTree>
-      <p:nvGrpSpPr>
-        <p:cNvPr id="1" name=""/>
-        <p:cNvGrpSpPr/>
-        <p:nvPr/>
-      </p:nvGrpSpPr>
-      <p:grpSpPr/>
-      <p:sp>
-        <p:nvSpPr>
-          <p:cNvPr id="2" name="TextBox 1"/>
-          <p:cNvSpPr txBox="1"/>
-          <p:nvPr/>
-        </p:nvSpPr>
-        <p:spPr>
-          <a:xfrm>
-            <a:off x="457200" y="228600"/>
-            <a:ext cx="11247120" cy="914400"/>
-          </a:xfrm>
-          <a:prstGeom prst="rect">
-            <a:avLst/>
-          </a:prstGeom>
-          <a:noFill/>
-        </p:spPr>
-        <p:txBody>
-          <a:bodyPr wrap="square">
-            <a:spAutoFit/>
-          </a:bodyPr>
-          <a:lstStyle/>
-          <a:p>
-            <a:r>
-              <a:rPr sz="2400" b="1">
-                <a:solidFill>
-                  <a:srgbClr val="1F3A5F"/>
-                </a:solidFill>
-              </a:rPr>
-              <a:t>Data coverage &amp; the NWS advisory-threshold proxy</a:t>
-            </a:r>
-          </a:p>
-        </p:txBody>
-      </p:sp>
-      <p:sp>
-        <p:nvSpPr>
-          <p:cNvPr id="3" name="TextBox 2"/>
-          <p:cNvSpPr txBox="1"/>
-          <p:nvPr/>
-        </p:nvSpPr>
-        <p:spPr>
-          <a:xfrm>
-            <a:off x="548640" y="1325880"/>
-            <a:ext cx="11064240" cy="4937760"/>
-          </a:xfrm>
-          <a:prstGeom prst="rect">
-            <a:avLst/>
-          </a:prstGeom>
-          <a:noFill/>
-        </p:spPr>
-        <p:txBody>
-          <a:bodyPr wrap="square">
-            <a:spAutoFit/>
-          </a:bodyPr>
-          <a:lstStyle/>
-          <a:p>
-            <a:pPr>
-              <a:spcAft>
-                <a:spcPts val="500"/>
-              </a:spcAft>
-            </a:pPr>
-            <a:r>
-              <a:rPr sz="1400" b="1">
-                <a:solidFill>
-                  <a:srgbClr val="1F3A5F"/>
-                </a:solidFill>
-              </a:rPr>
-              <a:t>• DATA COVERAGE / IDW imputation (same for both definitions):</a:t>
-            </a:r>
-          </a:p>
-          <a:p>
-            <a:pPr lvl="1">
-              <a:spcAft>
-                <a:spcPts val="500"/>
-              </a:spcAft>
-            </a:pPr>
-            <a:r>
-              <a:rPr sz="1200" b="0">
-                <a:solidFill>
-                  <a:srgbClr val="555555"/>
-                </a:solidFill>
-              </a:rPr>
-              <a:t>   – ~13% of temperature county-days are inverse-distance interpolated; 22 counties have NO native station; 93 are fully native</a:t>
-            </a:r>
-          </a:p>
-          <a:p>
-            <a:pPr lvl="1">
-              <a:spcAft>
-                <a:spcPts val="500"/>
-              </a:spcAft>
-            </a:pPr>
-            <a:r>
-              <a:rPr sz="1200" b="0">
-                <a:solidFill>
-                  <a:srgbClr val="555555"/>
-                </a:solidFill>
-              </a:rPr>
-              <a:t>   – =&gt; single-county map texture is noisy; the REGIONAL gradient is the trustworthy signal (see map03)</a:t>
-            </a:r>
-          </a:p>
-          <a:p>
-            <a:pPr>
-              <a:spcAft>
-                <a:spcPts val="500"/>
-              </a:spcAft>
-            </a:pPr>
-            <a:r>
-              <a:rPr sz="1400" b="1">
-                <a:solidFill>
-                  <a:srgbClr val="1F3A5F"/>
-                </a:solidFill>
-              </a:rPr>
-              <a:t>• NWS advisory-threshold PROXY (uses the daily-MAX HI vs each county's local office threshold):</a:t>
-            </a:r>
-          </a:p>
-          <a:p>
-            <a:pPr lvl="1">
-              <a:spcAft>
-                <a:spcPts val="500"/>
-              </a:spcAft>
-            </a:pPr>
-            <a:r>
-              <a:rPr sz="1200" b="0">
-                <a:solidFill>
-                  <a:srgbClr val="555555"/>
-                </a:solidFill>
-              </a:rPr>
-              <a:t>   – humid eastern/coastal counties accumulate many advisory-threshold days; arid far-west counties record almost none</a:t>
-            </a:r>
-          </a:p>
-          <a:p>
-            <a:pPr lvl="1">
-              <a:spcAft>
-                <a:spcPts val="500"/>
-              </a:spcAft>
-            </a:pPr>
-            <a:r>
-              <a:rPr sz="1200" b="0">
-                <a:solidFill>
-                  <a:srgbClr val="555555"/>
-                </a:solidFill>
-              </a:rPr>
-              <a:t>   – =&gt; a day can be a RELATIVE heatwave without reaching an ABSOLUTE advisory level (relative vs absolute heat)</a:t>
-            </a:r>
-          </a:p>
-          <a:p>
-            <a:pPr lvl="1">
-              <a:spcAft>
-                <a:spcPts val="500"/>
-              </a:spcAft>
-            </a:pPr>
-            <a:r>
-              <a:rPr sz="1200" b="0">
-                <a:solidFill>
-                  <a:srgbClr val="555555"/>
-                </a:solidFill>
-              </a:rPr>
-              <a:t>   – PROXY only — not an official NWS advisory (no hourly data, no duration/overnight/coverage rules)</a:t>
-            </a:r>
-          </a:p>
-        </p:txBody>
-      </p:sp>
-    </p:spTree>
-  </p:cSld>
-  <p:clrMapOvr>
-    <a:masterClrMapping/>
-  </p:clrMapOvr>
-</p:sld>
-</file>
-
-<file path=ppt/slides/slide16.xml><?xml version="1.0" encoding="utf-8"?>
-<p:sld xmlns:a="http://schemas.openxmlformats.org/drawingml/2006/main" xmlns:p="http://schemas.openxmlformats.org/presentationml/2006/main" xmlns:r="http://schemas.openxmlformats.org/officeDocument/2006/relationships">
-  <p:cSld>
-    <p:spTree>
-      <p:nvGrpSpPr>
-        <p:cNvPr id="1" name=""/>
-        <p:cNvGrpSpPr/>
-        <p:nvPr/>
-      </p:nvGrpSpPr>
-      <p:grpSpPr/>
-      <p:sp>
-        <p:nvSpPr>
-          <p:cNvPr id="2" name="Rectangle 1"/>
-          <p:cNvSpPr/>
-          <p:nvPr/>
-        </p:nvSpPr>
-        <p:spPr>
-          <a:xfrm>
-            <a:off x="0" y="2651760"/>
-            <a:ext cx="12191695" cy="1371600"/>
-          </a:xfrm>
-          <a:prstGeom prst="rect">
-            <a:avLst/>
-          </a:prstGeom>
-          <a:solidFill>
-            <a:srgbClr val="1F3A5F"/>
-          </a:solidFill>
-          <a:ln>
-            <a:noFill/>
-          </a:ln>
-        </p:spPr>
-        <p:style>
-          <a:lnRef idx="1">
-            <a:schemeClr val="accent1"/>
-          </a:lnRef>
-          <a:fillRef idx="3">
-            <a:schemeClr val="accent1"/>
-          </a:fillRef>
-          <a:effectRef idx="2">
-            <a:schemeClr val="accent1"/>
-          </a:effectRef>
-          <a:fontRef idx="minor">
-            <a:schemeClr val="lt1"/>
-          </a:fontRef>
-        </p:style>
-        <p:txBody>
-          <a:bodyPr rtlCol="0" anchor="ctr" lIns="548640"/>
-          <a:lstStyle/>
-          <a:p>
-            <a:pPr algn="l"/>
-            <a:r>
-              <a:rPr sz="2800" b="1">
-                <a:solidFill>
-                  <a:srgbClr val="FFFFFF"/>
-                </a:solidFill>
-              </a:rPr>
-              <a:t>Likely / scenario questions</a:t>
-            </a:r>
-          </a:p>
-        </p:txBody>
-      </p:sp>
-    </p:spTree>
-  </p:cSld>
-  <p:clrMapOvr>
-    <a:masterClrMapping/>
-  </p:clrMapOvr>
-</p:sld>
-</file>
-
-<file path=ppt/slides/slide17.xml><?xml version="1.0" encoding="utf-8"?>
-<p:sld xmlns:a="http://schemas.openxmlformats.org/drawingml/2006/main" xmlns:p="http://schemas.openxmlformats.org/presentationml/2006/main" xmlns:r="http://schemas.openxmlformats.org/officeDocument/2006/relationships">
-  <p:cSld>
-    <p:spTree>
-      <p:nvGrpSpPr>
-        <p:cNvPr id="1" name=""/>
-        <p:cNvGrpSpPr/>
-        <p:nvPr/>
-      </p:nvGrpSpPr>
-      <p:grpSpPr/>
-      <p:sp>
-        <p:nvSpPr>
-          <p:cNvPr id="2" name="TextBox 1"/>
-          <p:cNvSpPr txBox="1"/>
-          <p:nvPr/>
-        </p:nvSpPr>
-        <p:spPr>
-          <a:xfrm>
-            <a:off x="457200" y="228600"/>
-            <a:ext cx="11247120" cy="914400"/>
-          </a:xfrm>
-          <a:prstGeom prst="rect">
-            <a:avLst/>
-          </a:prstGeom>
-          <a:noFill/>
-        </p:spPr>
-        <p:txBody>
-          <a:bodyPr wrap="square">
-            <a:spAutoFit/>
-          </a:bodyPr>
-          <a:lstStyle/>
-          <a:p>
-            <a:r>
-              <a:rPr sz="2400" b="1">
-                <a:solidFill>
-                  <a:srgbClr val="1F3A5F"/>
-                </a:solidFill>
-              </a:rPr>
-              <a:t>Likely questions — construct &amp; metric</a:t>
-            </a:r>
-          </a:p>
-        </p:txBody>
-      </p:sp>
-      <p:sp>
-        <p:nvSpPr>
-          <p:cNvPr id="3" name="TextBox 2"/>
-          <p:cNvSpPr txBox="1"/>
-          <p:nvPr/>
-        </p:nvSpPr>
-        <p:spPr>
-          <a:xfrm>
-            <a:off x="548640" y="1325880"/>
-            <a:ext cx="11064240" cy="5029200"/>
-          </a:xfrm>
-          <a:prstGeom prst="rect">
-            <a:avLst/>
-          </a:prstGeom>
-          <a:noFill/>
-        </p:spPr>
-        <p:txBody>
-          <a:bodyPr wrap="square">
-            <a:spAutoFit/>
-          </a:bodyPr>
-          <a:lstStyle/>
-          <a:p>
-            <a:pPr>
-              <a:spcBef>
-                <a:spcPts val="600"/>
-              </a:spcBef>
-            </a:pPr>
-            <a:r>
-              <a:rPr sz="1300" b="1">
-                <a:solidFill>
-                  <a:srgbClr val="1F3A5F"/>
-                </a:solidFill>
-              </a:rPr>
-              <a:t>Q: Only ~37% of days are in summer — how is a warm January day a 'heatwave'?</a:t>
-            </a:r>
-          </a:p>
-          <a:p>
-            <a:r>
-              <a:rPr sz="1100">
-                <a:solidFill>
-                  <a:srgbClr val="555555"/>
-                </a:solidFill>
-              </a:rPr>
-              <a:t>A: By design: a year-round, county-relative rule flags days unusual FOR THE DATE, not absolutely hot. ~63% are cool-season anomalies. Apply the optional mean-HI&gt;=80°F floor (roughly halves counts) or a warm-season restriction for an absolute-heat framing.</a:t>
-            </a:r>
-          </a:p>
-          <a:p>
-            <a:pPr>
-              <a:spcBef>
-                <a:spcPts val="600"/>
-              </a:spcBef>
-            </a:pPr>
-            <a:r>
-              <a:rPr sz="1300" b="1">
-                <a:solidFill>
-                  <a:srgbClr val="1F3A5F"/>
-                </a:solidFill>
-              </a:rPr>
-              <a:t>Q: Why a daily-MEAN heat index — doesn't heat illness come from the afternoon peak?</a:t>
-            </a:r>
-          </a:p>
-          <a:p>
-            <a:r>
-              <a:rPr sz="1100">
-                <a:solidFill>
-                  <a:srgbClr val="555555"/>
-                </a:solidFill>
-              </a:rPr>
-              <a:t>A: The mean targets persistent day-and-night apparent heat (incl. warm nights). Trade-off: it under-weights the peak and is a DAILY PROXY, not hourly — so this is exposure CLASSIFICATION, not worker dose.</a:t>
-            </a:r>
-          </a:p>
-          <a:p>
-            <a:pPr>
-              <a:spcBef>
-                <a:spcPts val="600"/>
-              </a:spcBef>
-            </a:pPr>
-            <a:r>
-              <a:rPr sz="1300" b="1">
-                <a:solidFill>
-                  <a:srgbClr val="1F3A5F"/>
-                </a:solidFill>
-              </a:rPr>
-              <a:t>Q: Heat index is defined on hourly data — how valid is a daily proxy?</a:t>
-            </a:r>
-          </a:p>
-          <a:p>
-            <a:r>
-              <a:rPr sz="1100">
-                <a:solidFill>
-                  <a:srgbClr val="555555"/>
-                </a:solidFill>
-              </a:rPr>
-              <a:t>A: It's an approximate NWS proxy from GHCN-Daily temp + gridMET humidity. Regional gradient robust; single-county values &amp; trend slopes are descriptive only.</a:t>
-            </a:r>
-          </a:p>
-        </p:txBody>
-      </p:sp>
-    </p:spTree>
-  </p:cSld>
-  <p:clrMapOvr>
-    <a:masterClrMapping/>
-  </p:clrMapOvr>
-</p:sld>
-</file>
-
-<file path=ppt/slides/slide18.xml><?xml version="1.0" encoding="utf-8"?>
-<p:sld xmlns:a="http://schemas.openxmlformats.org/drawingml/2006/main" xmlns:p="http://schemas.openxmlformats.org/presentationml/2006/main" xmlns:r="http://schemas.openxmlformats.org/officeDocument/2006/relationships">
-  <p:cSld>
-    <p:spTree>
-      <p:nvGrpSpPr>
-        <p:cNvPr id="1" name=""/>
-        <p:cNvGrpSpPr/>
-        <p:nvPr/>
-      </p:nvGrpSpPr>
-      <p:grpSpPr/>
-      <p:sp>
-        <p:nvSpPr>
-          <p:cNvPr id="2" name="TextBox 1"/>
-          <p:cNvSpPr txBox="1"/>
-          <p:nvPr/>
-        </p:nvSpPr>
-        <p:spPr>
-          <a:xfrm>
-            <a:off x="457200" y="228600"/>
-            <a:ext cx="11247120" cy="914400"/>
-          </a:xfrm>
-          <a:prstGeom prst="rect">
-            <a:avLst/>
-          </a:prstGeom>
-          <a:noFill/>
-        </p:spPr>
-        <p:txBody>
-          <a:bodyPr wrap="square">
-            <a:spAutoFit/>
-          </a:bodyPr>
-          <a:lstStyle/>
-          <a:p>
-            <a:r>
-              <a:rPr sz="2400" b="1">
-                <a:solidFill>
-                  <a:srgbClr val="1F3A5F"/>
-                </a:solidFill>
-              </a:rPr>
-              <a:t>Likely questions — data quality &amp; persistence</a:t>
-            </a:r>
-          </a:p>
-        </p:txBody>
-      </p:sp>
-      <p:sp>
-        <p:nvSpPr>
-          <p:cNvPr id="3" name="TextBox 2"/>
-          <p:cNvSpPr txBox="1"/>
-          <p:nvPr/>
-        </p:nvSpPr>
-        <p:spPr>
-          <a:xfrm>
-            <a:off x="548640" y="1325880"/>
-            <a:ext cx="11064240" cy="5029200"/>
-          </a:xfrm>
-          <a:prstGeom prst="rect">
-            <a:avLst/>
-          </a:prstGeom>
-          <a:noFill/>
-        </p:spPr>
-        <p:txBody>
-          <a:bodyPr wrap="square">
-            <a:spAutoFit/>
-          </a:bodyPr>
-          <a:lstStyle/>
-          <a:p>
-            <a:pPr>
-              <a:spcBef>
-                <a:spcPts val="600"/>
-              </a:spcBef>
-            </a:pPr>
-            <a:r>
-              <a:rPr sz="1300" b="1">
-                <a:solidFill>
-                  <a:srgbClr val="1F3A5F"/>
-                </a:solidFill>
-              </a:rPr>
-              <a:t>Q: With ~13% of county-days imputed and 22 counties fully imputed, can I trust the maps?</a:t>
-            </a:r>
-          </a:p>
-          <a:p>
-            <a:r>
-              <a:rPr sz="1100">
-                <a:solidFill>
-                  <a:srgbClr val="555555"/>
-                </a:solidFill>
-              </a:rPr>
-              <a:t>A: Regionally yes, pixel-by-pixel no. Fully-imputed counties are interpolated, not observed — flag/exclude them for single-county claims. Statewide totals don't hinge on any one county.</a:t>
-            </a:r>
-          </a:p>
-          <a:p>
-            <a:pPr>
-              <a:spcBef>
-                <a:spcPts val="600"/>
-              </a:spcBef>
-            </a:pPr>
-            <a:r>
-              <a:rPr sz="1300" b="1">
-                <a:solidFill>
-                  <a:srgbClr val="1F3A5F"/>
-                </a:solidFill>
-              </a:rPr>
-              <a:t>Q: Is a 2-day exceedance really a 'wave', and is a 48-day event credible?</a:t>
-            </a:r>
-          </a:p>
-          <a:p>
-            <a:r>
-              <a:rPr sz="1100">
-                <a:solidFill>
-                  <a:srgbClr val="555555"/>
-                </a:solidFill>
-              </a:rPr>
-              <a:t>A: The &gt;=2-day rule is a minimum-persistence filter; 44–53% of events are exactly 2 days, so 'elevated exposure' is fairer than 'wave' for much of it. Long tails are genuine persistent anomalies — lead with the median, not the max.</a:t>
-            </a:r>
-          </a:p>
-          <a:p>
-            <a:pPr>
-              <a:spcBef>
-                <a:spcPts val="600"/>
-              </a:spcBef>
-            </a:pPr>
-            <a:r>
-              <a:rPr sz="1300" b="1">
-                <a:solidFill>
-                  <a:srgbClr val="1F3A5F"/>
-                </a:solidFill>
-              </a:rPr>
-              <a:t>Q: Some adjacent counties differ sharply — is that real climate?</a:t>
-            </a:r>
-          </a:p>
-          <a:p>
-            <a:r>
-              <a:rPr sz="1100">
-                <a:solidFill>
-                  <a:srgbClr val="555555"/>
-                </a:solidFill>
-              </a:rPr>
-              <a:t>A: Largely no — it reflects the changing multi-station composite + IDW imputation, not micro-climate. That's why single-county rankings are presented cautiously.</a:t>
             </a:r>
           </a:p>
         </p:txBody>
@@ -4635,7 +4525,7 @@
                   <a:srgbClr val="1F3A5F"/>
                 </a:solidFill>
               </a:rPr>
-              <a:t>Likely questions — thresholds, windows &amp; claims</a:t>
+              <a:t>Data coverage &amp; the NWS advisory-threshold proxy</a:t>
             </a:r>
           </a:p>
         </p:txBody>
@@ -4649,7 +4539,7 @@
         <p:spPr>
           <a:xfrm>
             <a:off x="548640" y="1325880"/>
-            <a:ext cx="11064240" cy="5029200"/>
+            <a:ext cx="11064240" cy="4937760"/>
           </a:xfrm>
           <a:prstGeom prst="rect">
             <a:avLst/>
@@ -4663,102 +4553,107 @@
           <a:lstStyle/>
           <a:p>
             <a:pPr>
-              <a:spcBef>
-                <a:spcPts val="600"/>
-              </a:spcBef>
+              <a:spcAft>
+                <a:spcPts val="500"/>
+              </a:spcAft>
             </a:pPr>
             <a:r>
-              <a:rPr sz="1300" b="1">
+              <a:rPr sz="1400" b="1">
                 <a:solidFill>
                   <a:srgbClr val="1F3A5F"/>
                 </a:solidFill>
               </a:rPr>
-              <a:t>Q: Why 85th and 95th specifically — aren't those arbitrary?</a:t>
-            </a:r>
-          </a:p>
-          <a:p>
-            <a:r>
-              <a:rPr sz="1100">
+              <a:t>• DATA COVERAGE / IDW imputation (same for both definitions):</a:t>
+            </a:r>
+          </a:p>
+          <a:p>
+            <a:pPr lvl="1">
+              <a:spcAft>
+                <a:spcPts val="500"/>
+              </a:spcAft>
+            </a:pPr>
+            <a:r>
+              <a:rPr sz="1200" b="0">
                 <a:solidFill>
                   <a:srgbClr val="555555"/>
                 </a:solidFill>
               </a:rPr>
-              <a:t>A: Conventional relative heat thresholds (95th has published precedent), chosen to bracket a moderate and a severe cut. A fuller threshold sweep is a reasonable extension.</a:t>
+              <a:t>   – ~13% of temperature county-days are inverse-distance interpolated; 22 counties have NO native station; 93 are fully native</a:t>
+            </a:r>
+          </a:p>
+          <a:p>
+            <a:pPr lvl="1">
+              <a:spcAft>
+                <a:spcPts val="500"/>
+              </a:spcAft>
+            </a:pPr>
+            <a:r>
+              <a:rPr sz="1200" b="0">
+                <a:solidFill>
+                  <a:srgbClr val="555555"/>
+                </a:solidFill>
+              </a:rPr>
+              <a:t>   – =&gt; single-county map texture is noisy; the REGIONAL gradient is the trustworthy signal (see map03)</a:t>
             </a:r>
           </a:p>
           <a:p>
             <a:pPr>
-              <a:spcBef>
-                <a:spcPts val="600"/>
-              </a:spcBef>
+              <a:spcAft>
+                <a:spcPts val="500"/>
+              </a:spcAft>
             </a:pPr>
             <a:r>
-              <a:rPr sz="1300" b="1">
+              <a:rPr sz="1400" b="1">
                 <a:solidFill>
                   <a:srgbClr val="1F3A5F"/>
                 </a:solidFill>
               </a:rPr>
-              <a:t>Q: A percentile fixes the exceedance rate — isn't the day count preordained?</a:t>
-            </a:r>
-          </a:p>
-          <a:p>
-            <a:r>
-              <a:rPr sz="1100">
+              <a:t>• NWS advisory-threshold PROXY (uses the daily-MAX HI vs each county's local office threshold):</a:t>
+            </a:r>
+          </a:p>
+          <a:p>
+            <a:pPr lvl="1">
+              <a:spcAft>
+                <a:spcPts val="500"/>
+              </a:spcAft>
+            </a:pPr>
+            <a:r>
+              <a:rPr sz="1200" b="0">
                 <a:solidFill>
                   <a:srgbClr val="555555"/>
                 </a:solidFill>
               </a:rPr>
-              <a:t>A: The single-day rate is anchored (~15% / ~5%), but totals also depend on the &gt;=2-day rule and the walk-forward baseline. The informative content is WHERE and WHEN heat clusters, not the grand total.</a:t>
-            </a:r>
-          </a:p>
-          <a:p>
-            <a:pPr>
-              <a:spcBef>
-                <a:spcPts val="600"/>
-              </a:spcBef>
+              <a:t>   – humid eastern/coastal counties accumulate many advisory-threshold days; arid far-west counties record almost none</a:t>
+            </a:r>
+          </a:p>
+          <a:p>
+            <a:pPr lvl="1">
+              <a:spcAft>
+                <a:spcPts val="500"/>
+              </a:spcAft>
             </a:pPr>
             <a:r>
-              <a:rPr sz="1300" b="1">
-                <a:solidFill>
-                  <a:srgbClr val="1F3A5F"/>
-                </a:solidFill>
-              </a:rPr>
-              <a:t>Q: How sensitive are results to the 15-day window vs a calendar month?</a:t>
-            </a:r>
-          </a:p>
-          <a:p>
-            <a:r>
-              <a:rPr sz="1100">
+              <a:rPr sz="1200" b="0">
                 <a:solidFill>
                   <a:srgbClr val="555555"/>
                 </a:solidFill>
               </a:rPr>
-              <a:t>A: Not sensitive — the two windows agree at r≈0.99 per county. The consequential levers are the percentile and the floor/season choice.</a:t>
-            </a:r>
-          </a:p>
-          <a:p>
-            <a:pPr>
-              <a:spcBef>
-                <a:spcPts val="600"/>
-              </a:spcBef>
+              <a:t>   – =&gt; a day can be a RELATIVE heatwave without reaching an ABSOLUTE advisory level (relative vs absolute heat)</a:t>
+            </a:r>
+          </a:p>
+          <a:p>
+            <a:pPr lvl="1">
+              <a:spcAft>
+                <a:spcPts val="500"/>
+              </a:spcAft>
             </a:pPr>
             <a:r>
-              <a:rPr sz="1300" b="1">
-                <a:solidFill>
-                  <a:srgbClr val="1F3A5F"/>
-                </a:solidFill>
-              </a:rPr>
-              <a:t>Q: What can these results actually support?</a:t>
-            </a:r>
-          </a:p>
-          <a:p>
-            <a:r>
-              <a:rPr sz="1100">
+              <a:rPr sz="1200" b="0">
                 <a:solidFill>
                   <a:srgbClr val="555555"/>
                 </a:solidFill>
               </a:rPr>
-              <a:t>A: County-level environmental apparent-heat EXPOSURE classification — not worker dose, causal injury, or official-advisory equivalence.</a:t>
+              <a:t>   – PROXY only — not an official NWS advisory (no hourly data, no duration/overnight/coverage rules)</a:t>
             </a:r>
           </a:p>
         </p:txBody>
@@ -4990,7 +4885,7 @@
             <a:avLst/>
           </a:prstGeom>
           <a:solidFill>
-            <a:srgbClr val="C44E52"/>
+            <a:srgbClr val="1F3A5F"/>
           </a:solidFill>
           <a:ln>
             <a:noFill/>
@@ -5021,7 +4916,7 @@
                   <a:srgbClr val="FFFFFF"/>
                 </a:solidFill>
               </a:rPr>
-              <a:t>Caveats to keep on any results slide</a:t>
+              <a:t>Likely / scenario questions</a:t>
             </a:r>
           </a:p>
         </p:txBody>
@@ -5035,6 +4930,547 @@
 </file>
 
 <file path=ppt/slides/slide21.xml><?xml version="1.0" encoding="utf-8"?>
+<p:sld xmlns:a="http://schemas.openxmlformats.org/drawingml/2006/main" xmlns:p="http://schemas.openxmlformats.org/presentationml/2006/main" xmlns:r="http://schemas.openxmlformats.org/officeDocument/2006/relationships">
+  <p:cSld>
+    <p:spTree>
+      <p:nvGrpSpPr>
+        <p:cNvPr id="1" name=""/>
+        <p:cNvGrpSpPr/>
+        <p:nvPr/>
+      </p:nvGrpSpPr>
+      <p:grpSpPr/>
+      <p:sp>
+        <p:nvSpPr>
+          <p:cNvPr id="2" name="TextBox 1"/>
+          <p:cNvSpPr txBox="1"/>
+          <p:nvPr/>
+        </p:nvSpPr>
+        <p:spPr>
+          <a:xfrm>
+            <a:off x="457200" y="228600"/>
+            <a:ext cx="11247120" cy="914400"/>
+          </a:xfrm>
+          <a:prstGeom prst="rect">
+            <a:avLst/>
+          </a:prstGeom>
+          <a:noFill/>
+        </p:spPr>
+        <p:txBody>
+          <a:bodyPr wrap="square">
+            <a:spAutoFit/>
+          </a:bodyPr>
+          <a:lstStyle/>
+          <a:p>
+            <a:r>
+              <a:rPr sz="2400" b="1">
+                <a:solidFill>
+                  <a:srgbClr val="1F3A5F"/>
+                </a:solidFill>
+              </a:rPr>
+              <a:t>Likely questions — construct &amp; metric</a:t>
+            </a:r>
+          </a:p>
+        </p:txBody>
+      </p:sp>
+      <p:sp>
+        <p:nvSpPr>
+          <p:cNvPr id="3" name="TextBox 2"/>
+          <p:cNvSpPr txBox="1"/>
+          <p:nvPr/>
+        </p:nvSpPr>
+        <p:spPr>
+          <a:xfrm>
+            <a:off x="548640" y="1325880"/>
+            <a:ext cx="11064240" cy="5029200"/>
+          </a:xfrm>
+          <a:prstGeom prst="rect">
+            <a:avLst/>
+          </a:prstGeom>
+          <a:noFill/>
+        </p:spPr>
+        <p:txBody>
+          <a:bodyPr wrap="square">
+            <a:spAutoFit/>
+          </a:bodyPr>
+          <a:lstStyle/>
+          <a:p>
+            <a:pPr>
+              <a:spcBef>
+                <a:spcPts val="600"/>
+              </a:spcBef>
+            </a:pPr>
+            <a:r>
+              <a:rPr sz="1300" b="1">
+                <a:solidFill>
+                  <a:srgbClr val="1F3A5F"/>
+                </a:solidFill>
+              </a:rPr>
+              <a:t>Q: Only ~37% of days are in summer — how is a warm January day a 'heatwave'?</a:t>
+            </a:r>
+          </a:p>
+          <a:p>
+            <a:r>
+              <a:rPr sz="1100">
+                <a:solidFill>
+                  <a:srgbClr val="555555"/>
+                </a:solidFill>
+              </a:rPr>
+              <a:t>A: By design: a year-round, county-relative rule flags days unusual FOR THE DATE, not absolutely hot. ~63% are cool-season anomalies. Apply the optional mean-HI&gt;=80°F floor (roughly halves counts) or a warm-season restriction for an absolute-heat framing.</a:t>
+            </a:r>
+          </a:p>
+          <a:p>
+            <a:pPr>
+              <a:spcBef>
+                <a:spcPts val="600"/>
+              </a:spcBef>
+            </a:pPr>
+            <a:r>
+              <a:rPr sz="1300" b="1">
+                <a:solidFill>
+                  <a:srgbClr val="1F3A5F"/>
+                </a:solidFill>
+              </a:rPr>
+              <a:t>Q: Why a daily-MEAN heat index — doesn't heat illness come from the afternoon peak?</a:t>
+            </a:r>
+          </a:p>
+          <a:p>
+            <a:r>
+              <a:rPr sz="1100">
+                <a:solidFill>
+                  <a:srgbClr val="555555"/>
+                </a:solidFill>
+              </a:rPr>
+              <a:t>A: The mean targets persistent day-and-night apparent heat (incl. warm nights). Trade-off: it under-weights the peak and is a DAILY PROXY, not hourly — so this is exposure CLASSIFICATION, not worker dose.</a:t>
+            </a:r>
+          </a:p>
+          <a:p>
+            <a:pPr>
+              <a:spcBef>
+                <a:spcPts val="600"/>
+              </a:spcBef>
+            </a:pPr>
+            <a:r>
+              <a:rPr sz="1300" b="1">
+                <a:solidFill>
+                  <a:srgbClr val="1F3A5F"/>
+                </a:solidFill>
+              </a:rPr>
+              <a:t>Q: Heat index is defined on hourly data — how valid is a daily proxy?</a:t>
+            </a:r>
+          </a:p>
+          <a:p>
+            <a:r>
+              <a:rPr sz="1100">
+                <a:solidFill>
+                  <a:srgbClr val="555555"/>
+                </a:solidFill>
+              </a:rPr>
+              <a:t>A: It's an approximate NWS proxy from GHCN-Daily temp + gridMET humidity. Regional gradient robust; single-county values &amp; trend slopes are descriptive only.</a:t>
+            </a:r>
+          </a:p>
+        </p:txBody>
+      </p:sp>
+    </p:spTree>
+  </p:cSld>
+  <p:clrMapOvr>
+    <a:masterClrMapping/>
+  </p:clrMapOvr>
+</p:sld>
+</file>
+
+<file path=ppt/slides/slide22.xml><?xml version="1.0" encoding="utf-8"?>
+<p:sld xmlns:a="http://schemas.openxmlformats.org/drawingml/2006/main" xmlns:p="http://schemas.openxmlformats.org/presentationml/2006/main" xmlns:r="http://schemas.openxmlformats.org/officeDocument/2006/relationships">
+  <p:cSld>
+    <p:spTree>
+      <p:nvGrpSpPr>
+        <p:cNvPr id="1" name=""/>
+        <p:cNvGrpSpPr/>
+        <p:nvPr/>
+      </p:nvGrpSpPr>
+      <p:grpSpPr/>
+      <p:sp>
+        <p:nvSpPr>
+          <p:cNvPr id="2" name="TextBox 1"/>
+          <p:cNvSpPr txBox="1"/>
+          <p:nvPr/>
+        </p:nvSpPr>
+        <p:spPr>
+          <a:xfrm>
+            <a:off x="457200" y="228600"/>
+            <a:ext cx="11247120" cy="914400"/>
+          </a:xfrm>
+          <a:prstGeom prst="rect">
+            <a:avLst/>
+          </a:prstGeom>
+          <a:noFill/>
+        </p:spPr>
+        <p:txBody>
+          <a:bodyPr wrap="square">
+            <a:spAutoFit/>
+          </a:bodyPr>
+          <a:lstStyle/>
+          <a:p>
+            <a:r>
+              <a:rPr sz="2400" b="1">
+                <a:solidFill>
+                  <a:srgbClr val="1F3A5F"/>
+                </a:solidFill>
+              </a:rPr>
+              <a:t>Likely questions — data quality &amp; persistence</a:t>
+            </a:r>
+          </a:p>
+        </p:txBody>
+      </p:sp>
+      <p:sp>
+        <p:nvSpPr>
+          <p:cNvPr id="3" name="TextBox 2"/>
+          <p:cNvSpPr txBox="1"/>
+          <p:nvPr/>
+        </p:nvSpPr>
+        <p:spPr>
+          <a:xfrm>
+            <a:off x="548640" y="1325880"/>
+            <a:ext cx="11064240" cy="5029200"/>
+          </a:xfrm>
+          <a:prstGeom prst="rect">
+            <a:avLst/>
+          </a:prstGeom>
+          <a:noFill/>
+        </p:spPr>
+        <p:txBody>
+          <a:bodyPr wrap="square">
+            <a:spAutoFit/>
+          </a:bodyPr>
+          <a:lstStyle/>
+          <a:p>
+            <a:pPr>
+              <a:spcBef>
+                <a:spcPts val="600"/>
+              </a:spcBef>
+            </a:pPr>
+            <a:r>
+              <a:rPr sz="1300" b="1">
+                <a:solidFill>
+                  <a:srgbClr val="1F3A5F"/>
+                </a:solidFill>
+              </a:rPr>
+              <a:t>Q: With ~13% of county-days imputed and 22 counties fully imputed, can I trust the maps?</a:t>
+            </a:r>
+          </a:p>
+          <a:p>
+            <a:r>
+              <a:rPr sz="1100">
+                <a:solidFill>
+                  <a:srgbClr val="555555"/>
+                </a:solidFill>
+              </a:rPr>
+              <a:t>A: Regionally yes, pixel-by-pixel no. Fully-imputed counties are interpolated, not observed — flag/exclude them for single-county claims. Statewide totals don't hinge on any one county.</a:t>
+            </a:r>
+          </a:p>
+          <a:p>
+            <a:pPr>
+              <a:spcBef>
+                <a:spcPts val="600"/>
+              </a:spcBef>
+            </a:pPr>
+            <a:r>
+              <a:rPr sz="1300" b="1">
+                <a:solidFill>
+                  <a:srgbClr val="1F3A5F"/>
+                </a:solidFill>
+              </a:rPr>
+              <a:t>Q: Is a 2-day exceedance really a 'wave', and is a 48-day event credible?</a:t>
+            </a:r>
+          </a:p>
+          <a:p>
+            <a:r>
+              <a:rPr sz="1100">
+                <a:solidFill>
+                  <a:srgbClr val="555555"/>
+                </a:solidFill>
+              </a:rPr>
+              <a:t>A: The &gt;=2-day rule is a minimum-persistence filter; 44–53% of events are exactly 2 days, so 'elevated exposure' is fairer than 'wave' for much of it. Long tails are genuine persistent anomalies — lead with the median, not the max.</a:t>
+            </a:r>
+          </a:p>
+          <a:p>
+            <a:pPr>
+              <a:spcBef>
+                <a:spcPts val="600"/>
+              </a:spcBef>
+            </a:pPr>
+            <a:r>
+              <a:rPr sz="1300" b="1">
+                <a:solidFill>
+                  <a:srgbClr val="1F3A5F"/>
+                </a:solidFill>
+              </a:rPr>
+              <a:t>Q: Some adjacent counties differ sharply — is that real climate?</a:t>
+            </a:r>
+          </a:p>
+          <a:p>
+            <a:r>
+              <a:rPr sz="1100">
+                <a:solidFill>
+                  <a:srgbClr val="555555"/>
+                </a:solidFill>
+              </a:rPr>
+              <a:t>A: Largely no — it reflects the changing multi-station composite + IDW imputation, not micro-climate. That's why single-county rankings are presented cautiously.</a:t>
+            </a:r>
+          </a:p>
+        </p:txBody>
+      </p:sp>
+    </p:spTree>
+  </p:cSld>
+  <p:clrMapOvr>
+    <a:masterClrMapping/>
+  </p:clrMapOvr>
+</p:sld>
+</file>
+
+<file path=ppt/slides/slide23.xml><?xml version="1.0" encoding="utf-8"?>
+<p:sld xmlns:a="http://schemas.openxmlformats.org/drawingml/2006/main" xmlns:p="http://schemas.openxmlformats.org/presentationml/2006/main" xmlns:r="http://schemas.openxmlformats.org/officeDocument/2006/relationships">
+  <p:cSld>
+    <p:spTree>
+      <p:nvGrpSpPr>
+        <p:cNvPr id="1" name=""/>
+        <p:cNvGrpSpPr/>
+        <p:nvPr/>
+      </p:nvGrpSpPr>
+      <p:grpSpPr/>
+      <p:sp>
+        <p:nvSpPr>
+          <p:cNvPr id="2" name="TextBox 1"/>
+          <p:cNvSpPr txBox="1"/>
+          <p:nvPr/>
+        </p:nvSpPr>
+        <p:spPr>
+          <a:xfrm>
+            <a:off x="457200" y="228600"/>
+            <a:ext cx="11247120" cy="914400"/>
+          </a:xfrm>
+          <a:prstGeom prst="rect">
+            <a:avLst/>
+          </a:prstGeom>
+          <a:noFill/>
+        </p:spPr>
+        <p:txBody>
+          <a:bodyPr wrap="square">
+            <a:spAutoFit/>
+          </a:bodyPr>
+          <a:lstStyle/>
+          <a:p>
+            <a:r>
+              <a:rPr sz="2400" b="1">
+                <a:solidFill>
+                  <a:srgbClr val="1F3A5F"/>
+                </a:solidFill>
+              </a:rPr>
+              <a:t>Likely questions — thresholds, windows &amp; claims</a:t>
+            </a:r>
+          </a:p>
+        </p:txBody>
+      </p:sp>
+      <p:sp>
+        <p:nvSpPr>
+          <p:cNvPr id="3" name="TextBox 2"/>
+          <p:cNvSpPr txBox="1"/>
+          <p:nvPr/>
+        </p:nvSpPr>
+        <p:spPr>
+          <a:xfrm>
+            <a:off x="548640" y="1325880"/>
+            <a:ext cx="11064240" cy="5029200"/>
+          </a:xfrm>
+          <a:prstGeom prst="rect">
+            <a:avLst/>
+          </a:prstGeom>
+          <a:noFill/>
+        </p:spPr>
+        <p:txBody>
+          <a:bodyPr wrap="square">
+            <a:spAutoFit/>
+          </a:bodyPr>
+          <a:lstStyle/>
+          <a:p>
+            <a:pPr>
+              <a:spcBef>
+                <a:spcPts val="600"/>
+              </a:spcBef>
+            </a:pPr>
+            <a:r>
+              <a:rPr sz="1300" b="1">
+                <a:solidFill>
+                  <a:srgbClr val="1F3A5F"/>
+                </a:solidFill>
+              </a:rPr>
+              <a:t>Q: Why 85th and 95th specifically — aren't those arbitrary?</a:t>
+            </a:r>
+          </a:p>
+          <a:p>
+            <a:r>
+              <a:rPr sz="1100">
+                <a:solidFill>
+                  <a:srgbClr val="555555"/>
+                </a:solidFill>
+              </a:rPr>
+              <a:t>A: Conventional relative heat thresholds (95th has published precedent), chosen to bracket a moderate and a severe cut. A fuller threshold sweep is a reasonable extension.</a:t>
+            </a:r>
+          </a:p>
+          <a:p>
+            <a:pPr>
+              <a:spcBef>
+                <a:spcPts val="600"/>
+              </a:spcBef>
+            </a:pPr>
+            <a:r>
+              <a:rPr sz="1300" b="1">
+                <a:solidFill>
+                  <a:srgbClr val="1F3A5F"/>
+                </a:solidFill>
+              </a:rPr>
+              <a:t>Q: A percentile fixes the exceedance rate — isn't the day count preordained?</a:t>
+            </a:r>
+          </a:p>
+          <a:p>
+            <a:r>
+              <a:rPr sz="1100">
+                <a:solidFill>
+                  <a:srgbClr val="555555"/>
+                </a:solidFill>
+              </a:rPr>
+              <a:t>A: The single-day rate is anchored (~15% / ~5%), but totals also depend on the &gt;=2-day rule and the walk-forward baseline. The informative content is WHERE and WHEN heat clusters, not the grand total.</a:t>
+            </a:r>
+          </a:p>
+          <a:p>
+            <a:pPr>
+              <a:spcBef>
+                <a:spcPts val="600"/>
+              </a:spcBef>
+            </a:pPr>
+            <a:r>
+              <a:rPr sz="1300" b="1">
+                <a:solidFill>
+                  <a:srgbClr val="1F3A5F"/>
+                </a:solidFill>
+              </a:rPr>
+              <a:t>Q: How sensitive are results to the 15-day window vs a calendar month?</a:t>
+            </a:r>
+          </a:p>
+          <a:p>
+            <a:r>
+              <a:rPr sz="1100">
+                <a:solidFill>
+                  <a:srgbClr val="555555"/>
+                </a:solidFill>
+              </a:rPr>
+              <a:t>A: Not sensitive — the two windows agree at r≈0.99 per county. The consequential levers are the percentile and the floor/season choice.</a:t>
+            </a:r>
+          </a:p>
+          <a:p>
+            <a:pPr>
+              <a:spcBef>
+                <a:spcPts val="600"/>
+              </a:spcBef>
+            </a:pPr>
+            <a:r>
+              <a:rPr sz="1300" b="1">
+                <a:solidFill>
+                  <a:srgbClr val="1F3A5F"/>
+                </a:solidFill>
+              </a:rPr>
+              <a:t>Q: What can these results actually support?</a:t>
+            </a:r>
+          </a:p>
+          <a:p>
+            <a:r>
+              <a:rPr sz="1100">
+                <a:solidFill>
+                  <a:srgbClr val="555555"/>
+                </a:solidFill>
+              </a:rPr>
+              <a:t>A: County-level environmental apparent-heat EXPOSURE classification — not worker dose, causal injury, or official-advisory equivalence.</a:t>
+            </a:r>
+          </a:p>
+        </p:txBody>
+      </p:sp>
+    </p:spTree>
+  </p:cSld>
+  <p:clrMapOvr>
+    <a:masterClrMapping/>
+  </p:clrMapOvr>
+</p:sld>
+</file>
+
+<file path=ppt/slides/slide24.xml><?xml version="1.0" encoding="utf-8"?>
+<p:sld xmlns:a="http://schemas.openxmlformats.org/drawingml/2006/main" xmlns:p="http://schemas.openxmlformats.org/presentationml/2006/main" xmlns:r="http://schemas.openxmlformats.org/officeDocument/2006/relationships">
+  <p:cSld>
+    <p:spTree>
+      <p:nvGrpSpPr>
+        <p:cNvPr id="1" name=""/>
+        <p:cNvGrpSpPr/>
+        <p:nvPr/>
+      </p:nvGrpSpPr>
+      <p:grpSpPr/>
+      <p:sp>
+        <p:nvSpPr>
+          <p:cNvPr id="2" name="Rectangle 1"/>
+          <p:cNvSpPr/>
+          <p:nvPr/>
+        </p:nvSpPr>
+        <p:spPr>
+          <a:xfrm>
+            <a:off x="0" y="2651760"/>
+            <a:ext cx="12191695" cy="1371600"/>
+          </a:xfrm>
+          <a:prstGeom prst="rect">
+            <a:avLst/>
+          </a:prstGeom>
+          <a:solidFill>
+            <a:srgbClr val="C44E52"/>
+          </a:solidFill>
+          <a:ln>
+            <a:noFill/>
+          </a:ln>
+        </p:spPr>
+        <p:style>
+          <a:lnRef idx="1">
+            <a:schemeClr val="accent1"/>
+          </a:lnRef>
+          <a:fillRef idx="3">
+            <a:schemeClr val="accent1"/>
+          </a:fillRef>
+          <a:effectRef idx="2">
+            <a:schemeClr val="accent1"/>
+          </a:effectRef>
+          <a:fontRef idx="minor">
+            <a:schemeClr val="lt1"/>
+          </a:fontRef>
+        </p:style>
+        <p:txBody>
+          <a:bodyPr rtlCol="0" anchor="ctr" lIns="548640"/>
+          <a:lstStyle/>
+          <a:p>
+            <a:pPr algn="l"/>
+            <a:r>
+              <a:rPr sz="2800" b="1">
+                <a:solidFill>
+                  <a:srgbClr val="FFFFFF"/>
+                </a:solidFill>
+              </a:rPr>
+              <a:t>Caveats to keep on any results slide</a:t>
+            </a:r>
+          </a:p>
+        </p:txBody>
+      </p:sp>
+    </p:spTree>
+  </p:cSld>
+  <p:clrMapOvr>
+    <a:masterClrMapping/>
+  </p:clrMapOvr>
+</p:sld>
+</file>
+
+<file path=ppt/slides/slide25.xml><?xml version="1.0" encoding="utf-8"?>
 <p:sld xmlns:a="http://schemas.openxmlformats.org/drawingml/2006/main" xmlns:p="http://schemas.openxmlformats.org/presentationml/2006/main" xmlns:r="http://schemas.openxmlformats.org/officeDocument/2006/relationships">
   <p:cSld>
     <p:spTree>

</xml_diff>